<commit_message>
Update slides for last couple years run
</commit_message>
<xml_diff>
--- a/slides/0x100/0x100 – Introduction to the Introduction.pptx
+++ b/slides/0x100/0x100 – Introduction to the Introduction.pptx
@@ -6,17 +6,27 @@
   </p:sldMasterIdLst>
   <p:sldIdLst>
     <p:sldId id="256" r:id="rId2"/>
-    <p:sldId id="257" r:id="rId3"/>
-    <p:sldId id="258" r:id="rId4"/>
-    <p:sldId id="267" r:id="rId5"/>
-    <p:sldId id="268" r:id="rId6"/>
-    <p:sldId id="259" r:id="rId7"/>
-    <p:sldId id="261" r:id="rId8"/>
-    <p:sldId id="262" r:id="rId9"/>
-    <p:sldId id="263" r:id="rId10"/>
-    <p:sldId id="266" r:id="rId11"/>
-    <p:sldId id="264" r:id="rId12"/>
-    <p:sldId id="265" r:id="rId13"/>
+    <p:sldId id="278" r:id="rId3"/>
+    <p:sldId id="277" r:id="rId4"/>
+    <p:sldId id="257" r:id="rId5"/>
+    <p:sldId id="258" r:id="rId6"/>
+    <p:sldId id="267" r:id="rId7"/>
+    <p:sldId id="282" r:id="rId8"/>
+    <p:sldId id="283" r:id="rId9"/>
+    <p:sldId id="268" r:id="rId10"/>
+    <p:sldId id="259" r:id="rId11"/>
+    <p:sldId id="279" r:id="rId12"/>
+    <p:sldId id="280" r:id="rId13"/>
+    <p:sldId id="269" r:id="rId14"/>
+    <p:sldId id="270" r:id="rId15"/>
+    <p:sldId id="261" r:id="rId16"/>
+    <p:sldId id="262" r:id="rId17"/>
+    <p:sldId id="263" r:id="rId18"/>
+    <p:sldId id="266" r:id="rId19"/>
+    <p:sldId id="264" r:id="rId20"/>
+    <p:sldId id="265" r:id="rId21"/>
+    <p:sldId id="281" r:id="rId22"/>
+    <p:sldId id="272" r:id="rId23"/>
   </p:sldIdLst>
   <p:sldSz cx="12192000" cy="6858000"/>
   <p:notesSz cx="6858000" cy="9144000"/>
@@ -272,7 +282,7 @@
           <a:p>
             <a:fld id="{76485C7A-D989-467D-AF24-38697A6F93C0}" type="datetimeFigureOut">
               <a:rPr lang="en-CA" smtClean="0"/>
-              <a:t>2023-09-06</a:t>
+              <a:t>2026-01-08</a:t>
             </a:fld>
             <a:endParaRPr lang="en-CA"/>
           </a:p>
@@ -472,7 +482,7 @@
           <a:p>
             <a:fld id="{76485C7A-D989-467D-AF24-38697A6F93C0}" type="datetimeFigureOut">
               <a:rPr lang="en-CA" smtClean="0"/>
-              <a:t>2023-09-06</a:t>
+              <a:t>2026-01-08</a:t>
             </a:fld>
             <a:endParaRPr lang="en-CA"/>
           </a:p>
@@ -682,7 +692,7 @@
           <a:p>
             <a:fld id="{76485C7A-D989-467D-AF24-38697A6F93C0}" type="datetimeFigureOut">
               <a:rPr lang="en-CA" smtClean="0"/>
-              <a:t>2023-09-06</a:t>
+              <a:t>2026-01-08</a:t>
             </a:fld>
             <a:endParaRPr lang="en-CA"/>
           </a:p>
@@ -882,7 +892,7 @@
           <a:p>
             <a:fld id="{76485C7A-D989-467D-AF24-38697A6F93C0}" type="datetimeFigureOut">
               <a:rPr lang="en-CA" smtClean="0"/>
-              <a:t>2023-09-06</a:t>
+              <a:t>2026-01-08</a:t>
             </a:fld>
             <a:endParaRPr lang="en-CA"/>
           </a:p>
@@ -1158,7 +1168,7 @@
           <a:p>
             <a:fld id="{76485C7A-D989-467D-AF24-38697A6F93C0}" type="datetimeFigureOut">
               <a:rPr lang="en-CA" smtClean="0"/>
-              <a:t>2023-09-06</a:t>
+              <a:t>2026-01-08</a:t>
             </a:fld>
             <a:endParaRPr lang="en-CA"/>
           </a:p>
@@ -1426,7 +1436,7 @@
           <a:p>
             <a:fld id="{76485C7A-D989-467D-AF24-38697A6F93C0}" type="datetimeFigureOut">
               <a:rPr lang="en-CA" smtClean="0"/>
-              <a:t>2023-09-06</a:t>
+              <a:t>2026-01-08</a:t>
             </a:fld>
             <a:endParaRPr lang="en-CA"/>
           </a:p>
@@ -1841,7 +1851,7 @@
           <a:p>
             <a:fld id="{76485C7A-D989-467D-AF24-38697A6F93C0}" type="datetimeFigureOut">
               <a:rPr lang="en-CA" smtClean="0"/>
-              <a:t>2023-09-06</a:t>
+              <a:t>2026-01-08</a:t>
             </a:fld>
             <a:endParaRPr lang="en-CA"/>
           </a:p>
@@ -1983,7 +1993,7 @@
           <a:p>
             <a:fld id="{76485C7A-D989-467D-AF24-38697A6F93C0}" type="datetimeFigureOut">
               <a:rPr lang="en-CA" smtClean="0"/>
-              <a:t>2023-09-06</a:t>
+              <a:t>2026-01-08</a:t>
             </a:fld>
             <a:endParaRPr lang="en-CA"/>
           </a:p>
@@ -2096,7 +2106,7 @@
           <a:p>
             <a:fld id="{76485C7A-D989-467D-AF24-38697A6F93C0}" type="datetimeFigureOut">
               <a:rPr lang="en-CA" smtClean="0"/>
-              <a:t>2023-09-06</a:t>
+              <a:t>2026-01-08</a:t>
             </a:fld>
             <a:endParaRPr lang="en-CA"/>
           </a:p>
@@ -2409,7 +2419,7 @@
           <a:p>
             <a:fld id="{76485C7A-D989-467D-AF24-38697A6F93C0}" type="datetimeFigureOut">
               <a:rPr lang="en-CA" smtClean="0"/>
-              <a:t>2023-09-06</a:t>
+              <a:t>2026-01-08</a:t>
             </a:fld>
             <a:endParaRPr lang="en-CA"/>
           </a:p>
@@ -2698,7 +2708,7 @@
           <a:p>
             <a:fld id="{76485C7A-D989-467D-AF24-38697A6F93C0}" type="datetimeFigureOut">
               <a:rPr lang="en-CA" smtClean="0"/>
-              <a:t>2023-09-06</a:t>
+              <a:t>2026-01-08</a:t>
             </a:fld>
             <a:endParaRPr lang="en-CA"/>
           </a:p>
@@ -2941,7 +2951,7 @@
           <a:p>
             <a:fld id="{76485C7A-D989-467D-AF24-38697A6F93C0}" type="datetimeFigureOut">
               <a:rPr lang="en-CA" smtClean="0"/>
-              <a:t>2023-09-06</a:t>
+              <a:t>2026-01-08</a:t>
             </a:fld>
             <a:endParaRPr lang="en-CA"/>
           </a:p>
@@ -3473,7 +3483,7 @@
           <p:cNvPr id="2" name="Title 1">
             <a:extLst>
               <a:ext uri="{FF2B5EF4-FFF2-40B4-BE49-F238E27FC236}">
-                <a16:creationId xmlns:a16="http://schemas.microsoft.com/office/drawing/2014/main" id="{D362A507-388C-48D4-A149-8F6BF0349009}"/>
+                <a16:creationId xmlns:a16="http://schemas.microsoft.com/office/drawing/2014/main" id="{505070EA-A2BA-4038-B982-862098C0430B}"/>
               </a:ext>
             </a:extLst>
           </p:cNvPr>
@@ -3491,7 +3501,7 @@
           <a:p>
             <a:r>
               <a:rPr lang="en-US" dirty="0"/>
-              <a:t>Labs</a:t>
+              <a:t>Course Lecture Style</a:t>
             </a:r>
             <a:endParaRPr lang="en-CA" dirty="0"/>
           </a:p>
@@ -3502,7 +3512,7 @@
           <p:cNvPr id="3" name="Content Placeholder 2">
             <a:extLst>
               <a:ext uri="{FF2B5EF4-FFF2-40B4-BE49-F238E27FC236}">
-                <a16:creationId xmlns:a16="http://schemas.microsoft.com/office/drawing/2014/main" id="{23978C3C-3E92-44F2-A9DF-D38084B9FBD4}"/>
+                <a16:creationId xmlns:a16="http://schemas.microsoft.com/office/drawing/2014/main" id="{7A6F966A-DAE3-4AFC-AC52-05F594C5937E}"/>
               </a:ext>
             </a:extLst>
           </p:cNvPr>
@@ -3513,29 +3523,126 @@
             <p:ph idx="1"/>
           </p:nvPr>
         </p:nvSpPr>
-        <p:spPr/>
-        <p:txBody>
-          <a:bodyPr/>
+        <p:spPr>
+          <a:xfrm>
+            <a:off x="838200" y="1623848"/>
+            <a:ext cx="10515600" cy="4553115"/>
+          </a:xfrm>
+        </p:spPr>
+        <p:txBody>
+          <a:bodyPr>
+            <a:normAutofit fontScale="77500" lnSpcReduction="20000"/>
+          </a:bodyPr>
           <a:lstStyle/>
           <a:p>
             <a:r>
               <a:rPr lang="en-US" dirty="0"/>
-              <a:t>Labs were previously run on everyone's computers.</a:t>
+              <a:t>Class schedule is roughly as follows each day:</a:t>
             </a:r>
           </a:p>
           <a:p>
             <a:r>
               <a:rPr lang="en-US" dirty="0"/>
-              <a:t>We may run them in the lab room.</a:t>
-            </a:r>
+              <a:t>Tuesday @ 1:05PM – 2:25PM (B227)</a:t>
+            </a:r>
+          </a:p>
+          <a:p>
+            <a:r>
+              <a:rPr lang="en-US" dirty="0"/>
+              <a:t>Thursday @ 1:05PM – 2:25PM (B227)</a:t>
+            </a:r>
+          </a:p>
+          <a:p>
             <a:endParaRPr lang="en-CA" dirty="0"/>
+          </a:p>
+          <a:p>
+            <a:r>
+              <a:rPr lang="en-CA" dirty="0"/>
+              <a:t>+ Labs on Wednesday 2:35-5:25PM (not every week)</a:t>
+            </a:r>
+          </a:p>
+          <a:p>
+            <a:pPr marL="0" indent="0">
+              <a:buNone/>
+            </a:pPr>
+            <a:r>
+              <a:rPr lang="en-US" dirty="0"/>
+              <a:t>	</a:t>
+            </a:r>
+            <a:r>
+              <a:rPr lang="en-US" i="1" dirty="0"/>
+              <a:t>I teach as well during the start of that timeslot, a TA will be running labs.</a:t>
+            </a:r>
+            <a:endParaRPr lang="en-US" dirty="0"/>
+          </a:p>
+          <a:p>
+            <a:pPr marL="0" indent="0">
+              <a:buNone/>
+            </a:pPr>
+            <a:endParaRPr lang="en-US" dirty="0"/>
+          </a:p>
+          <a:p>
+            <a:pPr marL="0" indent="0">
+              <a:buNone/>
+            </a:pPr>
+            <a:r>
+              <a:rPr lang="en-US" dirty="0"/>
+              <a:t>Classes will </a:t>
+            </a:r>
+            <a:r>
+              <a:rPr lang="en-US" i="1" dirty="0"/>
+              <a:t>roughly</a:t>
+            </a:r>
+            <a:r>
+              <a:rPr lang="en-US" dirty="0"/>
+              <a:t> follow the schedule each day:</a:t>
+            </a:r>
+          </a:p>
+          <a:p>
+            <a:pPr marL="0" indent="0">
+              <a:buNone/>
+            </a:pPr>
+            <a:endParaRPr lang="en-US" dirty="0"/>
+          </a:p>
+          <a:p>
+            <a:pPr marL="0" indent="0">
+              <a:buNone/>
+            </a:pPr>
+            <a:r>
+              <a:rPr lang="en-US" dirty="0"/>
+              <a:t>2:35-2:45: Recap of previous lecture (possibly longer if needed).</a:t>
+            </a:r>
+          </a:p>
+          <a:p>
+            <a:pPr marL="0" indent="0">
+              <a:buNone/>
+            </a:pPr>
+            <a:r>
+              <a:rPr lang="en-US" dirty="0"/>
+              <a:t>2:45-3:30: New material / lectures (45 mins – ONLY this section recorded)</a:t>
+            </a:r>
+          </a:p>
+          <a:p>
+            <a:pPr marL="0" indent="0">
+              <a:buNone/>
+            </a:pPr>
+            <a:r>
+              <a:rPr lang="en-US" dirty="0"/>
+              <a:t>3:30-3:55: Questions &amp; discussions (if needed)</a:t>
+            </a:r>
+          </a:p>
+          <a:p>
+            <a:pPr marL="0" indent="0">
+              <a:buNone/>
+            </a:pPr>
+            <a:endParaRPr lang="en-US" dirty="0"/>
           </a:p>
         </p:txBody>
       </p:sp>
     </p:spTree>
     <p:extLst>
       <p:ext uri="{BB962C8B-B14F-4D97-AF65-F5344CB8AC3E}">
-        <p14:creationId xmlns:p14="http://schemas.microsoft.com/office/powerpoint/2010/main" val="3070855699"/>
+        <p14:creationId xmlns:p14="http://schemas.microsoft.com/office/powerpoint/2010/main" val="519975281"/>
       </p:ext>
     </p:extLst>
   </p:cSld>
@@ -3648,6 +3755,349 @@
                       </p:childTnLst>
                     </p:cTn>
                   </p:par>
+                  <p:par>
+                    <p:cTn id="11" fill="hold">
+                      <p:stCondLst>
+                        <p:cond delay="indefinite"/>
+                      </p:stCondLst>
+                      <p:childTnLst>
+                        <p:par>
+                          <p:cTn id="12" fill="hold">
+                            <p:stCondLst>
+                              <p:cond delay="0"/>
+                            </p:stCondLst>
+                            <p:childTnLst>
+                              <p:par>
+                                <p:cTn id="13" presetID="1" presetClass="entr" presetSubtype="0" fill="hold" grpId="0" nodeType="clickEffect">
+                                  <p:stCondLst>
+                                    <p:cond delay="0"/>
+                                  </p:stCondLst>
+                                  <p:childTnLst>
+                                    <p:set>
+                                      <p:cBhvr>
+                                        <p:cTn id="14" dur="1" fill="hold">
+                                          <p:stCondLst>
+                                            <p:cond delay="0"/>
+                                          </p:stCondLst>
+                                        </p:cTn>
+                                        <p:tgtEl>
+                                          <p:spTgt spid="3">
+                                            <p:txEl>
+                                              <p:pRg st="2" end="2"/>
+                                            </p:txEl>
+                                          </p:spTgt>
+                                        </p:tgtEl>
+                                        <p:attrNameLst>
+                                          <p:attrName>style.visibility</p:attrName>
+                                        </p:attrNameLst>
+                                      </p:cBhvr>
+                                      <p:to>
+                                        <p:strVal val="visible"/>
+                                      </p:to>
+                                    </p:set>
+                                  </p:childTnLst>
+                                </p:cTn>
+                              </p:par>
+                            </p:childTnLst>
+                          </p:cTn>
+                        </p:par>
+                      </p:childTnLst>
+                    </p:cTn>
+                  </p:par>
+                  <p:par>
+                    <p:cTn id="15" fill="hold">
+                      <p:stCondLst>
+                        <p:cond delay="indefinite"/>
+                      </p:stCondLst>
+                      <p:childTnLst>
+                        <p:par>
+                          <p:cTn id="16" fill="hold">
+                            <p:stCondLst>
+                              <p:cond delay="0"/>
+                            </p:stCondLst>
+                            <p:childTnLst>
+                              <p:par>
+                                <p:cTn id="17" presetID="1" presetClass="entr" presetSubtype="0" fill="hold" grpId="0" nodeType="clickEffect">
+                                  <p:stCondLst>
+                                    <p:cond delay="0"/>
+                                  </p:stCondLst>
+                                  <p:childTnLst>
+                                    <p:set>
+                                      <p:cBhvr>
+                                        <p:cTn id="18" dur="1" fill="hold">
+                                          <p:stCondLst>
+                                            <p:cond delay="0"/>
+                                          </p:stCondLst>
+                                        </p:cTn>
+                                        <p:tgtEl>
+                                          <p:spTgt spid="3">
+                                            <p:txEl>
+                                              <p:pRg st="4" end="4"/>
+                                            </p:txEl>
+                                          </p:spTgt>
+                                        </p:tgtEl>
+                                        <p:attrNameLst>
+                                          <p:attrName>style.visibility</p:attrName>
+                                        </p:attrNameLst>
+                                      </p:cBhvr>
+                                      <p:to>
+                                        <p:strVal val="visible"/>
+                                      </p:to>
+                                    </p:set>
+                                  </p:childTnLst>
+                                </p:cTn>
+                              </p:par>
+                            </p:childTnLst>
+                          </p:cTn>
+                        </p:par>
+                      </p:childTnLst>
+                    </p:cTn>
+                  </p:par>
+                  <p:par>
+                    <p:cTn id="19" fill="hold">
+                      <p:stCondLst>
+                        <p:cond delay="indefinite"/>
+                      </p:stCondLst>
+                      <p:childTnLst>
+                        <p:par>
+                          <p:cTn id="20" fill="hold">
+                            <p:stCondLst>
+                              <p:cond delay="0"/>
+                            </p:stCondLst>
+                            <p:childTnLst>
+                              <p:par>
+                                <p:cTn id="21" presetID="1" presetClass="entr" presetSubtype="0" fill="hold" grpId="0" nodeType="clickEffect">
+                                  <p:stCondLst>
+                                    <p:cond delay="0"/>
+                                  </p:stCondLst>
+                                  <p:childTnLst>
+                                    <p:set>
+                                      <p:cBhvr>
+                                        <p:cTn id="22" dur="1" fill="hold">
+                                          <p:stCondLst>
+                                            <p:cond delay="0"/>
+                                          </p:stCondLst>
+                                        </p:cTn>
+                                        <p:tgtEl>
+                                          <p:spTgt spid="3">
+                                            <p:txEl>
+                                              <p:pRg st="5" end="5"/>
+                                            </p:txEl>
+                                          </p:spTgt>
+                                        </p:tgtEl>
+                                        <p:attrNameLst>
+                                          <p:attrName>style.visibility</p:attrName>
+                                        </p:attrNameLst>
+                                      </p:cBhvr>
+                                      <p:to>
+                                        <p:strVal val="visible"/>
+                                      </p:to>
+                                    </p:set>
+                                  </p:childTnLst>
+                                </p:cTn>
+                              </p:par>
+                            </p:childTnLst>
+                          </p:cTn>
+                        </p:par>
+                      </p:childTnLst>
+                    </p:cTn>
+                  </p:par>
+                  <p:par>
+                    <p:cTn id="23" fill="hold">
+                      <p:stCondLst>
+                        <p:cond delay="indefinite"/>
+                      </p:stCondLst>
+                      <p:childTnLst>
+                        <p:par>
+                          <p:cTn id="24" fill="hold">
+                            <p:stCondLst>
+                              <p:cond delay="0"/>
+                            </p:stCondLst>
+                            <p:childTnLst>
+                              <p:par>
+                                <p:cTn id="25" presetID="1" presetClass="entr" presetSubtype="0" fill="hold" grpId="0" nodeType="clickEffect">
+                                  <p:stCondLst>
+                                    <p:cond delay="0"/>
+                                  </p:stCondLst>
+                                  <p:childTnLst>
+                                    <p:set>
+                                      <p:cBhvr>
+                                        <p:cTn id="26" dur="1" fill="hold">
+                                          <p:stCondLst>
+                                            <p:cond delay="0"/>
+                                          </p:stCondLst>
+                                        </p:cTn>
+                                        <p:tgtEl>
+                                          <p:spTgt spid="3">
+                                            <p:txEl>
+                                              <p:pRg st="7" end="7"/>
+                                            </p:txEl>
+                                          </p:spTgt>
+                                        </p:tgtEl>
+                                        <p:attrNameLst>
+                                          <p:attrName>style.visibility</p:attrName>
+                                        </p:attrNameLst>
+                                      </p:cBhvr>
+                                      <p:to>
+                                        <p:strVal val="visible"/>
+                                      </p:to>
+                                    </p:set>
+                                  </p:childTnLst>
+                                </p:cTn>
+                              </p:par>
+                            </p:childTnLst>
+                          </p:cTn>
+                        </p:par>
+                      </p:childTnLst>
+                    </p:cTn>
+                  </p:par>
+                  <p:par>
+                    <p:cTn id="27" fill="hold">
+                      <p:stCondLst>
+                        <p:cond delay="indefinite"/>
+                      </p:stCondLst>
+                      <p:childTnLst>
+                        <p:par>
+                          <p:cTn id="28" fill="hold">
+                            <p:stCondLst>
+                              <p:cond delay="0"/>
+                            </p:stCondLst>
+                            <p:childTnLst>
+                              <p:par>
+                                <p:cTn id="29" presetID="1" presetClass="entr" presetSubtype="0" fill="hold" grpId="0" nodeType="clickEffect">
+                                  <p:stCondLst>
+                                    <p:cond delay="0"/>
+                                  </p:stCondLst>
+                                  <p:childTnLst>
+                                    <p:set>
+                                      <p:cBhvr>
+                                        <p:cTn id="30" dur="1" fill="hold">
+                                          <p:stCondLst>
+                                            <p:cond delay="0"/>
+                                          </p:stCondLst>
+                                        </p:cTn>
+                                        <p:tgtEl>
+                                          <p:spTgt spid="3">
+                                            <p:txEl>
+                                              <p:pRg st="9" end="9"/>
+                                            </p:txEl>
+                                          </p:spTgt>
+                                        </p:tgtEl>
+                                        <p:attrNameLst>
+                                          <p:attrName>style.visibility</p:attrName>
+                                        </p:attrNameLst>
+                                      </p:cBhvr>
+                                      <p:to>
+                                        <p:strVal val="visible"/>
+                                      </p:to>
+                                    </p:set>
+                                  </p:childTnLst>
+                                </p:cTn>
+                              </p:par>
+                            </p:childTnLst>
+                          </p:cTn>
+                        </p:par>
+                      </p:childTnLst>
+                    </p:cTn>
+                  </p:par>
+                  <p:par>
+                    <p:cTn id="31" fill="hold">
+                      <p:stCondLst>
+                        <p:cond delay="indefinite"/>
+                      </p:stCondLst>
+                      <p:childTnLst>
+                        <p:par>
+                          <p:cTn id="32" fill="hold">
+                            <p:stCondLst>
+                              <p:cond delay="0"/>
+                            </p:stCondLst>
+                            <p:childTnLst>
+                              <p:par>
+                                <p:cTn id="33" presetID="1" presetClass="entr" presetSubtype="0" fill="hold" grpId="0" nodeType="clickEffect">
+                                  <p:stCondLst>
+                                    <p:cond delay="0"/>
+                                  </p:stCondLst>
+                                  <p:childTnLst>
+                                    <p:set>
+                                      <p:cBhvr>
+                                        <p:cTn id="34" dur="1" fill="hold">
+                                          <p:stCondLst>
+                                            <p:cond delay="0"/>
+                                          </p:stCondLst>
+                                        </p:cTn>
+                                        <p:tgtEl>
+                                          <p:spTgt spid="3">
+                                            <p:txEl>
+                                              <p:pRg st="10" end="10"/>
+                                            </p:txEl>
+                                          </p:spTgt>
+                                        </p:tgtEl>
+                                        <p:attrNameLst>
+                                          <p:attrName>style.visibility</p:attrName>
+                                        </p:attrNameLst>
+                                      </p:cBhvr>
+                                      <p:to>
+                                        <p:strVal val="visible"/>
+                                      </p:to>
+                                    </p:set>
+                                  </p:childTnLst>
+                                </p:cTn>
+                              </p:par>
+                            </p:childTnLst>
+                          </p:cTn>
+                        </p:par>
+                      </p:childTnLst>
+                    </p:cTn>
+                  </p:par>
+                  <p:par>
+                    <p:cTn id="35" fill="hold">
+                      <p:stCondLst>
+                        <p:cond delay="indefinite"/>
+                      </p:stCondLst>
+                      <p:childTnLst>
+                        <p:par>
+                          <p:cTn id="36" fill="hold">
+                            <p:stCondLst>
+                              <p:cond delay="0"/>
+                            </p:stCondLst>
+                            <p:childTnLst>
+                              <p:par>
+                                <p:cTn id="37" presetID="1" presetClass="entr" presetSubtype="0" fill="hold" grpId="0" nodeType="clickEffect">
+                                  <p:stCondLst>
+                                    <p:cond delay="0"/>
+                                  </p:stCondLst>
+                                  <p:childTnLst>
+                                    <p:set>
+                                      <p:cBhvr>
+                                        <p:cTn id="38" dur="1" fill="hold">
+                                          <p:stCondLst>
+                                            <p:cond delay="0"/>
+                                          </p:stCondLst>
+                                        </p:cTn>
+                                        <p:tgtEl>
+                                          <p:spTgt spid="3">
+                                            <p:txEl>
+                                              <p:pRg st="11" end="11"/>
+                                            </p:txEl>
+                                          </p:spTgt>
+                                        </p:tgtEl>
+                                        <p:attrNameLst>
+                                          <p:attrName>style.visibility</p:attrName>
+                                        </p:attrNameLst>
+                                      </p:cBhvr>
+                                      <p:to>
+                                        <p:strVal val="visible"/>
+                                      </p:to>
+                                    </p:set>
+                                  </p:childTnLst>
+                                </p:cTn>
+                              </p:par>
+                            </p:childTnLst>
+                          </p:cTn>
+                        </p:par>
+                      </p:childTnLst>
+                    </p:cTn>
+                  </p:par>
                 </p:childTnLst>
               </p:cTn>
               <p:prevCondLst>
@@ -3698,7 +4148,7 @@
           <p:cNvPr id="2" name="Title 1">
             <a:extLst>
               <a:ext uri="{FF2B5EF4-FFF2-40B4-BE49-F238E27FC236}">
-                <a16:creationId xmlns:a16="http://schemas.microsoft.com/office/drawing/2014/main" id="{96F6F40C-8FCD-4ED6-9F2E-2C0694D0F515}"/>
+                <a16:creationId xmlns:a16="http://schemas.microsoft.com/office/drawing/2014/main" id="{1C83B00F-3EAA-BEEC-4274-3431C271D67A}"/>
               </a:ext>
             </a:extLst>
           </p:cNvPr>
@@ -3715,51 +4165,137 @@
           <a:lstStyle/>
           <a:p>
             <a:r>
-              <a:rPr lang="en-US" dirty="0"/>
-              <a:t>Course Project</a:t>
-            </a:r>
+              <a:rPr lang="en-CA" dirty="0"/>
+              <a:t>Course Policies</a:t>
+            </a:r>
+          </a:p>
+        </p:txBody>
+      </p:sp>
+      <p:sp>
+        <p:nvSpPr>
+          <p:cNvPr id="3" name="Content Placeholder 2">
+            <a:extLst>
+              <a:ext uri="{FF2B5EF4-FFF2-40B4-BE49-F238E27FC236}">
+                <a16:creationId xmlns:a16="http://schemas.microsoft.com/office/drawing/2014/main" id="{94A96863-E56E-2ED1-DEB3-95B703333ADA}"/>
+              </a:ext>
+            </a:extLst>
+          </p:cNvPr>
+          <p:cNvSpPr>
+            <a:spLocks noGrp="1"/>
+          </p:cNvSpPr>
+          <p:nvPr>
+            <p:ph idx="1"/>
+          </p:nvPr>
+        </p:nvSpPr>
+        <p:spPr/>
+        <p:txBody>
+          <a:bodyPr>
+            <a:normAutofit lnSpcReduction="10000"/>
+          </a:bodyPr>
+          <a:lstStyle/>
+          <a:p>
+            <a:r>
+              <a:rPr lang="en-CA" dirty="0"/>
+              <a:t>If Dalhousie is closed due to snow event I </a:t>
+            </a:r>
+            <a:r>
+              <a:rPr lang="en-CA" i="1" dirty="0"/>
+              <a:t>will not </a:t>
+            </a:r>
+            <a:r>
+              <a:rPr lang="en-CA" dirty="0"/>
+              <a:t>send a notice, there is no class. If we have many cancellations I may need to record missing lectures (there is some “flex” built in right now) or will use Tutorial times.</a:t>
+            </a:r>
+          </a:p>
+          <a:p>
             <a:endParaRPr lang="en-CA" dirty="0"/>
           </a:p>
-        </p:txBody>
-      </p:sp>
-      <p:sp>
-        <p:nvSpPr>
-          <p:cNvPr id="3" name="Content Placeholder 2">
-            <a:extLst>
-              <a:ext uri="{FF2B5EF4-FFF2-40B4-BE49-F238E27FC236}">
-                <a16:creationId xmlns:a16="http://schemas.microsoft.com/office/drawing/2014/main" id="{18EAC01E-3FCC-4281-93CB-3E87F997C69F}"/>
-              </a:ext>
-            </a:extLst>
-          </p:cNvPr>
-          <p:cNvSpPr>
-            <a:spLocks noGrp="1"/>
-          </p:cNvSpPr>
-          <p:nvPr>
-            <p:ph idx="1"/>
-          </p:nvPr>
-        </p:nvSpPr>
-        <p:spPr/>
-        <p:txBody>
-          <a:bodyPr/>
-          <a:lstStyle/>
-          <a:p>
-            <a:r>
-              <a:rPr lang="en-US" dirty="0"/>
-              <a:t>Course project will be a chance to apply some of what you’ve learned in this course.</a:t>
-            </a:r>
-          </a:p>
-          <a:p>
-            <a:r>
-              <a:rPr lang="en-US" dirty="0"/>
-              <a:t>More details coming next month once you have more background on the material.</a:t>
-            </a:r>
+          <a:p>
+            <a:r>
+              <a:rPr lang="en-CA" dirty="0"/>
+              <a:t>If class will be cancelled for other reasons I will use Brightspace to announce this.</a:t>
+            </a:r>
+          </a:p>
+          <a:p>
+            <a:endParaRPr lang="en-CA" dirty="0"/>
+          </a:p>
+          <a:p>
+            <a:r>
+              <a:rPr lang="en-CA" dirty="0"/>
+              <a:t>Lab/Tutorials tend </a:t>
+            </a:r>
+            <a:r>
+              <a:rPr lang="en-CA" u="sng" dirty="0"/>
+              <a:t>not</a:t>
+            </a:r>
+            <a:r>
+              <a:rPr lang="en-CA" dirty="0"/>
+              <a:t> to run every week – look for a Brightspace announcement to confirm if a lab is running (NO LAB next week).</a:t>
+            </a:r>
+          </a:p>
+        </p:txBody>
+      </p:sp>
+      <p:sp>
+        <p:nvSpPr>
+          <p:cNvPr id="4" name="Date Placeholder 3">
+            <a:extLst>
+              <a:ext uri="{FF2B5EF4-FFF2-40B4-BE49-F238E27FC236}">
+                <a16:creationId xmlns:a16="http://schemas.microsoft.com/office/drawing/2014/main" id="{FAC46ADB-485B-F4FE-3BAF-4E8EBE78DD50}"/>
+              </a:ext>
+            </a:extLst>
+          </p:cNvPr>
+          <p:cNvSpPr>
+            <a:spLocks noGrp="1"/>
+          </p:cNvSpPr>
+          <p:nvPr>
+            <p:ph type="dt" sz="half" idx="10"/>
+          </p:nvPr>
+        </p:nvSpPr>
+        <p:spPr/>
+        <p:txBody>
+          <a:bodyPr/>
+          <a:lstStyle/>
+          <a:p>
+            <a:r>
+              <a:rPr lang="en-CA"/>
+              <a:t>Last Update: 2026-01-06</a:t>
+            </a:r>
+          </a:p>
+        </p:txBody>
+      </p:sp>
+      <p:sp>
+        <p:nvSpPr>
+          <p:cNvPr id="5" name="Footer Placeholder 4">
+            <a:extLst>
+              <a:ext uri="{FF2B5EF4-FFF2-40B4-BE49-F238E27FC236}">
+                <a16:creationId xmlns:a16="http://schemas.microsoft.com/office/drawing/2014/main" id="{06632044-6D97-2C2A-7371-76FA1F9A55F6}"/>
+              </a:ext>
+            </a:extLst>
+          </p:cNvPr>
+          <p:cNvSpPr>
+            <a:spLocks noGrp="1"/>
+          </p:cNvSpPr>
+          <p:nvPr>
+            <p:ph type="ftr" sz="quarter" idx="11"/>
+          </p:nvPr>
+        </p:nvSpPr>
+        <p:spPr/>
+        <p:txBody>
+          <a:bodyPr/>
+          <a:lstStyle/>
+          <a:p>
+            <a:r>
+              <a:rPr lang="en-US"/>
+              <a:t>ECED3403 Computer Architecture. Colin O'Flynn.</a:t>
+            </a:r>
+            <a:endParaRPr lang="en-CA"/>
           </a:p>
         </p:txBody>
       </p:sp>
     </p:spTree>
     <p:extLst>
       <p:ext uri="{BB962C8B-B14F-4D97-AF65-F5344CB8AC3E}">
-        <p14:creationId xmlns:p14="http://schemas.microsoft.com/office/powerpoint/2010/main" val="210414657"/>
+        <p14:creationId xmlns:p14="http://schemas.microsoft.com/office/powerpoint/2010/main" val="149294204"/>
       </p:ext>
     </p:extLst>
   </p:cSld>
@@ -3791,6 +4327,1196 @@
           <p:cNvPr id="2" name="Title 1">
             <a:extLst>
               <a:ext uri="{FF2B5EF4-FFF2-40B4-BE49-F238E27FC236}">
+                <a16:creationId xmlns:a16="http://schemas.microsoft.com/office/drawing/2014/main" id="{A925A676-633B-16F1-82AC-7DEE2616B408}"/>
+              </a:ext>
+            </a:extLst>
+          </p:cNvPr>
+          <p:cNvSpPr>
+            <a:spLocks noGrp="1"/>
+          </p:cNvSpPr>
+          <p:nvPr>
+            <p:ph type="title"/>
+          </p:nvPr>
+        </p:nvSpPr>
+        <p:spPr/>
+        <p:txBody>
+          <a:bodyPr/>
+          <a:lstStyle/>
+          <a:p>
+            <a:r>
+              <a:rPr lang="en-CA" dirty="0"/>
+              <a:t>Course Policies (From Syllabus)</a:t>
+            </a:r>
+          </a:p>
+        </p:txBody>
+      </p:sp>
+      <p:pic>
+        <p:nvPicPr>
+          <p:cNvPr id="5" name="Content Placeholder 4" descr="A close-up of a letter&#10;&#10;AI-generated content may be incorrect.">
+            <a:extLst>
+              <a:ext uri="{FF2B5EF4-FFF2-40B4-BE49-F238E27FC236}">
+                <a16:creationId xmlns:a16="http://schemas.microsoft.com/office/drawing/2014/main" id="{BC2E578D-DC23-6D34-5BC7-DD02B91C9442}"/>
+              </a:ext>
+            </a:extLst>
+          </p:cNvPr>
+          <p:cNvPicPr>
+            <a:picLocks noGrp="1" noChangeAspect="1"/>
+          </p:cNvPicPr>
+          <p:nvPr>
+            <p:ph idx="1"/>
+          </p:nvPr>
+        </p:nvPicPr>
+        <p:blipFill>
+          <a:blip r:embed="rId2"/>
+          <a:stretch>
+            <a:fillRect/>
+          </a:stretch>
+        </p:blipFill>
+        <p:spPr>
+          <a:xfrm>
+            <a:off x="838200" y="2321942"/>
+            <a:ext cx="10515600" cy="2444304"/>
+          </a:xfrm>
+          <a:prstGeom prst="rect">
+            <a:avLst/>
+          </a:prstGeom>
+        </p:spPr>
+      </p:pic>
+      <p:sp>
+        <p:nvSpPr>
+          <p:cNvPr id="8" name="Footer Placeholder 7">
+            <a:extLst>
+              <a:ext uri="{FF2B5EF4-FFF2-40B4-BE49-F238E27FC236}">
+                <a16:creationId xmlns:a16="http://schemas.microsoft.com/office/drawing/2014/main" id="{62A03D96-C0BF-77A8-933C-1E49C3BA1050}"/>
+              </a:ext>
+            </a:extLst>
+          </p:cNvPr>
+          <p:cNvSpPr>
+            <a:spLocks noGrp="1"/>
+          </p:cNvSpPr>
+          <p:nvPr>
+            <p:ph type="ftr" sz="quarter" idx="11"/>
+          </p:nvPr>
+        </p:nvSpPr>
+        <p:spPr/>
+        <p:txBody>
+          <a:bodyPr/>
+          <a:lstStyle/>
+          <a:p>
+            <a:r>
+              <a:rPr lang="en-US"/>
+              <a:t>ECED3403 Computer Architecture. Colin O'Flynn.</a:t>
+            </a:r>
+            <a:endParaRPr lang="en-CA"/>
+          </a:p>
+        </p:txBody>
+      </p:sp>
+      <p:sp>
+        <p:nvSpPr>
+          <p:cNvPr id="9" name="Date Placeholder 8">
+            <a:extLst>
+              <a:ext uri="{FF2B5EF4-FFF2-40B4-BE49-F238E27FC236}">
+                <a16:creationId xmlns:a16="http://schemas.microsoft.com/office/drawing/2014/main" id="{904F680C-DCD0-08E4-6E0C-57962BAB40F0}"/>
+              </a:ext>
+            </a:extLst>
+          </p:cNvPr>
+          <p:cNvSpPr>
+            <a:spLocks noGrp="1"/>
+          </p:cNvSpPr>
+          <p:nvPr>
+            <p:ph type="dt" sz="half" idx="10"/>
+          </p:nvPr>
+        </p:nvSpPr>
+        <p:spPr/>
+        <p:txBody>
+          <a:bodyPr/>
+          <a:lstStyle/>
+          <a:p>
+            <a:r>
+              <a:rPr lang="en-CA"/>
+              <a:t>Last Update: 2026-01-06</a:t>
+            </a:r>
+          </a:p>
+        </p:txBody>
+      </p:sp>
+    </p:spTree>
+    <p:extLst>
+      <p:ext uri="{BB962C8B-B14F-4D97-AF65-F5344CB8AC3E}">
+        <p14:creationId xmlns:p14="http://schemas.microsoft.com/office/powerpoint/2010/main" val="368538030"/>
+      </p:ext>
+    </p:extLst>
+  </p:cSld>
+  <p:clrMapOvr>
+    <a:masterClrMapping/>
+  </p:clrMapOvr>
+</p:sld>
+</file>
+
+<file path=ppt/slides/slide13.xml><?xml version="1.0" encoding="utf-8"?>
+<p:sld xmlns:a="http://schemas.openxmlformats.org/drawingml/2006/main" xmlns:r="http://schemas.openxmlformats.org/officeDocument/2006/relationships" xmlns:p="http://schemas.openxmlformats.org/presentationml/2006/main">
+  <p:cSld>
+    <p:spTree>
+      <p:nvGrpSpPr>
+        <p:cNvPr id="1" name="">
+          <a:extLst>
+            <a:ext uri="{FF2B5EF4-FFF2-40B4-BE49-F238E27FC236}">
+              <a16:creationId xmlns:a16="http://schemas.microsoft.com/office/drawing/2014/main" id="{102B7F3D-B914-8B48-E275-CF70600C8C38}"/>
+            </a:ext>
+          </a:extLst>
+        </p:cNvPr>
+        <p:cNvGrpSpPr/>
+        <p:nvPr/>
+      </p:nvGrpSpPr>
+      <p:grpSpPr>
+        <a:xfrm>
+          <a:off x="0" y="0"/>
+          <a:ext cx="0" cy="0"/>
+          <a:chOff x="0" y="0"/>
+          <a:chExt cx="0" cy="0"/>
+        </a:xfrm>
+      </p:grpSpPr>
+      <p:sp>
+        <p:nvSpPr>
+          <p:cNvPr id="2" name="Title 1">
+            <a:extLst>
+              <a:ext uri="{FF2B5EF4-FFF2-40B4-BE49-F238E27FC236}">
+                <a16:creationId xmlns:a16="http://schemas.microsoft.com/office/drawing/2014/main" id="{06AF0299-D417-A1D8-572A-7C1F2FCAB273}"/>
+              </a:ext>
+            </a:extLst>
+          </p:cNvPr>
+          <p:cNvSpPr>
+            <a:spLocks noGrp="1"/>
+          </p:cNvSpPr>
+          <p:nvPr>
+            <p:ph type="title"/>
+          </p:nvPr>
+        </p:nvSpPr>
+        <p:spPr/>
+        <p:txBody>
+          <a:bodyPr/>
+          <a:lstStyle/>
+          <a:p>
+            <a:r>
+              <a:rPr lang="en-CA" dirty="0"/>
+              <a:t>Course Policies (From Syllabus)</a:t>
+            </a:r>
+          </a:p>
+        </p:txBody>
+      </p:sp>
+      <p:sp>
+        <p:nvSpPr>
+          <p:cNvPr id="8" name="Footer Placeholder 7">
+            <a:extLst>
+              <a:ext uri="{FF2B5EF4-FFF2-40B4-BE49-F238E27FC236}">
+                <a16:creationId xmlns:a16="http://schemas.microsoft.com/office/drawing/2014/main" id="{1D901A5A-060B-1963-8AFA-E5E96364099B}"/>
+              </a:ext>
+            </a:extLst>
+          </p:cNvPr>
+          <p:cNvSpPr>
+            <a:spLocks noGrp="1"/>
+          </p:cNvSpPr>
+          <p:nvPr>
+            <p:ph type="ftr" sz="quarter" idx="11"/>
+          </p:nvPr>
+        </p:nvSpPr>
+        <p:spPr/>
+        <p:txBody>
+          <a:bodyPr/>
+          <a:lstStyle/>
+          <a:p>
+            <a:r>
+              <a:rPr lang="en-US"/>
+              <a:t>ECED3403 Computer Architecture. Colin O'Flynn.</a:t>
+            </a:r>
+            <a:endParaRPr lang="en-CA"/>
+          </a:p>
+        </p:txBody>
+      </p:sp>
+      <p:sp>
+        <p:nvSpPr>
+          <p:cNvPr id="9" name="Date Placeholder 8">
+            <a:extLst>
+              <a:ext uri="{FF2B5EF4-FFF2-40B4-BE49-F238E27FC236}">
+                <a16:creationId xmlns:a16="http://schemas.microsoft.com/office/drawing/2014/main" id="{E25FE2D6-4C65-98E4-64A8-2F6E69F04930}"/>
+              </a:ext>
+            </a:extLst>
+          </p:cNvPr>
+          <p:cNvSpPr>
+            <a:spLocks noGrp="1"/>
+          </p:cNvSpPr>
+          <p:nvPr>
+            <p:ph type="dt" sz="half" idx="10"/>
+          </p:nvPr>
+        </p:nvSpPr>
+        <p:spPr/>
+        <p:txBody>
+          <a:bodyPr/>
+          <a:lstStyle/>
+          <a:p>
+            <a:r>
+              <a:rPr lang="en-CA"/>
+              <a:t>Last Update: 2026-01-06</a:t>
+            </a:r>
+          </a:p>
+        </p:txBody>
+      </p:sp>
+      <p:pic>
+        <p:nvPicPr>
+          <p:cNvPr id="4" name="Picture 3" descr="A close-up of a text&#10;&#10;AI-generated content may be incorrect.">
+            <a:extLst>
+              <a:ext uri="{FF2B5EF4-FFF2-40B4-BE49-F238E27FC236}">
+                <a16:creationId xmlns:a16="http://schemas.microsoft.com/office/drawing/2014/main" id="{7AED09DC-0464-17B3-DD61-A986B17DD1C3}"/>
+              </a:ext>
+            </a:extLst>
+          </p:cNvPr>
+          <p:cNvPicPr>
+            <a:picLocks noChangeAspect="1"/>
+          </p:cNvPicPr>
+          <p:nvPr/>
+        </p:nvPicPr>
+        <p:blipFill>
+          <a:blip r:embed="rId2"/>
+          <a:stretch>
+            <a:fillRect/>
+          </a:stretch>
+        </p:blipFill>
+        <p:spPr>
+          <a:xfrm>
+            <a:off x="838200" y="1914940"/>
+            <a:ext cx="10774275" cy="3028120"/>
+          </a:xfrm>
+          <a:prstGeom prst="rect">
+            <a:avLst/>
+          </a:prstGeom>
+        </p:spPr>
+      </p:pic>
+    </p:spTree>
+    <p:extLst>
+      <p:ext uri="{BB962C8B-B14F-4D97-AF65-F5344CB8AC3E}">
+        <p14:creationId xmlns:p14="http://schemas.microsoft.com/office/powerpoint/2010/main" val="3605703039"/>
+      </p:ext>
+    </p:extLst>
+  </p:cSld>
+  <p:clrMapOvr>
+    <a:masterClrMapping/>
+  </p:clrMapOvr>
+</p:sld>
+</file>
+
+<file path=ppt/slides/slide14.xml><?xml version="1.0" encoding="utf-8"?>
+<p:sld xmlns:a="http://schemas.openxmlformats.org/drawingml/2006/main" xmlns:r="http://schemas.openxmlformats.org/officeDocument/2006/relationships" xmlns:p="http://schemas.openxmlformats.org/presentationml/2006/main">
+  <p:cSld>
+    <p:spTree>
+      <p:nvGrpSpPr>
+        <p:cNvPr id="1" name=""/>
+        <p:cNvGrpSpPr/>
+        <p:nvPr/>
+      </p:nvGrpSpPr>
+      <p:grpSpPr>
+        <a:xfrm>
+          <a:off x="0" y="0"/>
+          <a:ext cx="0" cy="0"/>
+          <a:chOff x="0" y="0"/>
+          <a:chExt cx="0" cy="0"/>
+        </a:xfrm>
+      </p:grpSpPr>
+      <p:sp>
+        <p:nvSpPr>
+          <p:cNvPr id="2" name="Title 1">
+            <a:extLst>
+              <a:ext uri="{FF2B5EF4-FFF2-40B4-BE49-F238E27FC236}">
+                <a16:creationId xmlns:a16="http://schemas.microsoft.com/office/drawing/2014/main" id="{B6AD5F32-8646-432A-B168-0236F7D74AC7}"/>
+              </a:ext>
+            </a:extLst>
+          </p:cNvPr>
+          <p:cNvSpPr>
+            <a:spLocks noGrp="1"/>
+          </p:cNvSpPr>
+          <p:nvPr>
+            <p:ph type="title"/>
+          </p:nvPr>
+        </p:nvSpPr>
+        <p:spPr/>
+        <p:txBody>
+          <a:bodyPr/>
+          <a:lstStyle/>
+          <a:p>
+            <a:r>
+              <a:rPr lang="en-CA" dirty="0"/>
+              <a:t>Course Policies (From Syllabus)</a:t>
+            </a:r>
+          </a:p>
+        </p:txBody>
+      </p:sp>
+      <p:pic>
+        <p:nvPicPr>
+          <p:cNvPr id="5" name="Content Placeholder 4" descr="A close-up of a document&#10;&#10;AI-generated content may be incorrect.">
+            <a:extLst>
+              <a:ext uri="{FF2B5EF4-FFF2-40B4-BE49-F238E27FC236}">
+                <a16:creationId xmlns:a16="http://schemas.microsoft.com/office/drawing/2014/main" id="{9D4C7567-E11A-F8F0-E1BD-647063BD8277}"/>
+              </a:ext>
+            </a:extLst>
+          </p:cNvPr>
+          <p:cNvPicPr>
+            <a:picLocks noGrp="1" noChangeAspect="1"/>
+          </p:cNvPicPr>
+          <p:nvPr>
+            <p:ph idx="1"/>
+          </p:nvPr>
+        </p:nvPicPr>
+        <p:blipFill>
+          <a:blip r:embed="rId2"/>
+          <a:stretch>
+            <a:fillRect/>
+          </a:stretch>
+        </p:blipFill>
+        <p:spPr>
+          <a:xfrm>
+            <a:off x="838200" y="1956223"/>
+            <a:ext cx="10515600" cy="4090141"/>
+          </a:xfrm>
+          <a:prstGeom prst="rect">
+            <a:avLst/>
+          </a:prstGeom>
+        </p:spPr>
+      </p:pic>
+      <p:sp>
+        <p:nvSpPr>
+          <p:cNvPr id="6" name="Footer Placeholder 5">
+            <a:extLst>
+              <a:ext uri="{FF2B5EF4-FFF2-40B4-BE49-F238E27FC236}">
+                <a16:creationId xmlns:a16="http://schemas.microsoft.com/office/drawing/2014/main" id="{45C62082-A085-8EED-3A8A-F32D6089AE6C}"/>
+              </a:ext>
+            </a:extLst>
+          </p:cNvPr>
+          <p:cNvSpPr>
+            <a:spLocks noGrp="1"/>
+          </p:cNvSpPr>
+          <p:nvPr>
+            <p:ph type="ftr" sz="quarter" idx="11"/>
+          </p:nvPr>
+        </p:nvSpPr>
+        <p:spPr/>
+        <p:txBody>
+          <a:bodyPr/>
+          <a:lstStyle/>
+          <a:p>
+            <a:r>
+              <a:rPr lang="en-US"/>
+              <a:t>ECED3403 Computer Architecture. Colin O'Flynn.</a:t>
+            </a:r>
+            <a:endParaRPr lang="en-CA"/>
+          </a:p>
+        </p:txBody>
+      </p:sp>
+      <p:sp>
+        <p:nvSpPr>
+          <p:cNvPr id="7" name="Date Placeholder 6">
+            <a:extLst>
+              <a:ext uri="{FF2B5EF4-FFF2-40B4-BE49-F238E27FC236}">
+                <a16:creationId xmlns:a16="http://schemas.microsoft.com/office/drawing/2014/main" id="{40FD0746-6595-1912-74B8-C22687BB2A63}"/>
+              </a:ext>
+            </a:extLst>
+          </p:cNvPr>
+          <p:cNvSpPr>
+            <a:spLocks noGrp="1"/>
+          </p:cNvSpPr>
+          <p:nvPr>
+            <p:ph type="dt" sz="half" idx="10"/>
+          </p:nvPr>
+        </p:nvSpPr>
+        <p:spPr/>
+        <p:txBody>
+          <a:bodyPr/>
+          <a:lstStyle/>
+          <a:p>
+            <a:r>
+              <a:rPr lang="en-CA"/>
+              <a:t>Last Update: 2026-01-06</a:t>
+            </a:r>
+          </a:p>
+        </p:txBody>
+      </p:sp>
+    </p:spTree>
+    <p:extLst>
+      <p:ext uri="{BB962C8B-B14F-4D97-AF65-F5344CB8AC3E}">
+        <p14:creationId xmlns:p14="http://schemas.microsoft.com/office/powerpoint/2010/main" val="979638840"/>
+      </p:ext>
+    </p:extLst>
+  </p:cSld>
+  <p:clrMapOvr>
+    <a:masterClrMapping/>
+  </p:clrMapOvr>
+</p:sld>
+</file>
+
+<file path=ppt/slides/slide15.xml><?xml version="1.0" encoding="utf-8"?>
+<p:sld xmlns:a="http://schemas.openxmlformats.org/drawingml/2006/main" xmlns:r="http://schemas.openxmlformats.org/officeDocument/2006/relationships" xmlns:p="http://schemas.openxmlformats.org/presentationml/2006/main">
+  <p:cSld>
+    <p:spTree>
+      <p:nvGrpSpPr>
+        <p:cNvPr id="1" name=""/>
+        <p:cNvGrpSpPr/>
+        <p:nvPr/>
+      </p:nvGrpSpPr>
+      <p:grpSpPr>
+        <a:xfrm>
+          <a:off x="0" y="0"/>
+          <a:ext cx="0" cy="0"/>
+          <a:chOff x="0" y="0"/>
+          <a:chExt cx="0" cy="0"/>
+        </a:xfrm>
+      </p:grpSpPr>
+      <p:sp>
+        <p:nvSpPr>
+          <p:cNvPr id="2" name="Title 1">
+            <a:extLst>
+              <a:ext uri="{FF2B5EF4-FFF2-40B4-BE49-F238E27FC236}">
+                <a16:creationId xmlns:a16="http://schemas.microsoft.com/office/drawing/2014/main" id="{566BE9AE-1FEC-417C-9C98-8FB3D8B3CF26}"/>
+              </a:ext>
+            </a:extLst>
+          </p:cNvPr>
+          <p:cNvSpPr>
+            <a:spLocks noGrp="1"/>
+          </p:cNvSpPr>
+          <p:nvPr>
+            <p:ph type="title"/>
+          </p:nvPr>
+        </p:nvSpPr>
+        <p:spPr/>
+        <p:txBody>
+          <a:bodyPr/>
+          <a:lstStyle/>
+          <a:p>
+            <a:r>
+              <a:rPr lang="en-US" dirty="0"/>
+              <a:t>Brightspace</a:t>
+            </a:r>
+            <a:endParaRPr lang="en-CA" dirty="0"/>
+          </a:p>
+        </p:txBody>
+      </p:sp>
+      <p:pic>
+        <p:nvPicPr>
+          <p:cNvPr id="5" name="Picture 4" descr="A screenshot of a computer security&#10;&#10;AI-generated content may be incorrect.">
+            <a:extLst>
+              <a:ext uri="{FF2B5EF4-FFF2-40B4-BE49-F238E27FC236}">
+                <a16:creationId xmlns:a16="http://schemas.microsoft.com/office/drawing/2014/main" id="{91526D8D-5C78-C731-4C11-2A374872AC2C}"/>
+              </a:ext>
+            </a:extLst>
+          </p:cNvPr>
+          <p:cNvPicPr>
+            <a:picLocks noChangeAspect="1"/>
+          </p:cNvPicPr>
+          <p:nvPr/>
+        </p:nvPicPr>
+        <p:blipFill>
+          <a:blip r:embed="rId2"/>
+          <a:stretch>
+            <a:fillRect/>
+          </a:stretch>
+        </p:blipFill>
+        <p:spPr>
+          <a:xfrm>
+            <a:off x="1289539" y="1454338"/>
+            <a:ext cx="8850923" cy="4799924"/>
+          </a:xfrm>
+          <a:prstGeom prst="rect">
+            <a:avLst/>
+          </a:prstGeom>
+        </p:spPr>
+      </p:pic>
+    </p:spTree>
+    <p:extLst>
+      <p:ext uri="{BB962C8B-B14F-4D97-AF65-F5344CB8AC3E}">
+        <p14:creationId xmlns:p14="http://schemas.microsoft.com/office/powerpoint/2010/main" val="2586454753"/>
+      </p:ext>
+    </p:extLst>
+  </p:cSld>
+  <p:clrMapOvr>
+    <a:masterClrMapping/>
+  </p:clrMapOvr>
+</p:sld>
+</file>
+
+<file path=ppt/slides/slide16.xml><?xml version="1.0" encoding="utf-8"?>
+<p:sld xmlns:a="http://schemas.openxmlformats.org/drawingml/2006/main" xmlns:r="http://schemas.openxmlformats.org/officeDocument/2006/relationships" xmlns:p="http://schemas.openxmlformats.org/presentationml/2006/main">
+  <p:cSld>
+    <p:spTree>
+      <p:nvGrpSpPr>
+        <p:cNvPr id="1" name=""/>
+        <p:cNvGrpSpPr/>
+        <p:nvPr/>
+      </p:nvGrpSpPr>
+      <p:grpSpPr>
+        <a:xfrm>
+          <a:off x="0" y="0"/>
+          <a:ext cx="0" cy="0"/>
+          <a:chOff x="0" y="0"/>
+          <a:chExt cx="0" cy="0"/>
+        </a:xfrm>
+      </p:grpSpPr>
+      <p:sp>
+        <p:nvSpPr>
+          <p:cNvPr id="2" name="Title 1">
+            <a:extLst>
+              <a:ext uri="{FF2B5EF4-FFF2-40B4-BE49-F238E27FC236}">
+                <a16:creationId xmlns:a16="http://schemas.microsoft.com/office/drawing/2014/main" id="{70A44A35-98C7-4518-99B2-C02BBE9E3AEF}"/>
+              </a:ext>
+            </a:extLst>
+          </p:cNvPr>
+          <p:cNvSpPr>
+            <a:spLocks noGrp="1"/>
+          </p:cNvSpPr>
+          <p:nvPr>
+            <p:ph type="title"/>
+          </p:nvPr>
+        </p:nvSpPr>
+        <p:spPr/>
+        <p:txBody>
+          <a:bodyPr/>
+          <a:lstStyle/>
+          <a:p>
+            <a:r>
+              <a:rPr lang="en-US" dirty="0"/>
+              <a:t>Quizzes</a:t>
+            </a:r>
+            <a:endParaRPr lang="en-CA" dirty="0"/>
+          </a:p>
+        </p:txBody>
+      </p:sp>
+      <p:sp>
+        <p:nvSpPr>
+          <p:cNvPr id="3" name="Content Placeholder 2">
+            <a:extLst>
+              <a:ext uri="{FF2B5EF4-FFF2-40B4-BE49-F238E27FC236}">
+                <a16:creationId xmlns:a16="http://schemas.microsoft.com/office/drawing/2014/main" id="{531A8316-AB8A-4AF3-A550-95303328884C}"/>
+              </a:ext>
+            </a:extLst>
+          </p:cNvPr>
+          <p:cNvSpPr>
+            <a:spLocks noGrp="1"/>
+          </p:cNvSpPr>
+          <p:nvPr>
+            <p:ph idx="1"/>
+          </p:nvPr>
+        </p:nvSpPr>
+        <p:spPr/>
+        <p:txBody>
+          <a:bodyPr/>
+          <a:lstStyle/>
+          <a:p>
+            <a:r>
+              <a:rPr lang="en-US" dirty="0"/>
+              <a:t>We will start quizzes next week – these cover some of the lecture topics.</a:t>
+            </a:r>
+          </a:p>
+          <a:p>
+            <a:pPr lvl="1"/>
+            <a:r>
+              <a:rPr lang="en-US" dirty="0"/>
+              <a:t>They should hopefully reinforce what you’ve learned in the lectures.</a:t>
+            </a:r>
+          </a:p>
+          <a:p>
+            <a:pPr lvl="1"/>
+            <a:r>
+              <a:rPr lang="en-US" dirty="0"/>
+              <a:t>They will run through the Brightspace system.</a:t>
+            </a:r>
+            <a:endParaRPr lang="en-CA" dirty="0"/>
+          </a:p>
+        </p:txBody>
+      </p:sp>
+    </p:spTree>
+    <p:extLst>
+      <p:ext uri="{BB962C8B-B14F-4D97-AF65-F5344CB8AC3E}">
+        <p14:creationId xmlns:p14="http://schemas.microsoft.com/office/powerpoint/2010/main" val="1255052836"/>
+      </p:ext>
+    </p:extLst>
+  </p:cSld>
+  <p:clrMapOvr>
+    <a:masterClrMapping/>
+  </p:clrMapOvr>
+</p:sld>
+</file>
+
+<file path=ppt/slides/slide17.xml><?xml version="1.0" encoding="utf-8"?>
+<p:sld xmlns:a="http://schemas.openxmlformats.org/drawingml/2006/main" xmlns:r="http://schemas.openxmlformats.org/officeDocument/2006/relationships" xmlns:p="http://schemas.openxmlformats.org/presentationml/2006/main">
+  <p:cSld>
+    <p:spTree>
+      <p:nvGrpSpPr>
+        <p:cNvPr id="1" name=""/>
+        <p:cNvGrpSpPr/>
+        <p:nvPr/>
+      </p:nvGrpSpPr>
+      <p:grpSpPr>
+        <a:xfrm>
+          <a:off x="0" y="0"/>
+          <a:ext cx="0" cy="0"/>
+          <a:chOff x="0" y="0"/>
+          <a:chExt cx="0" cy="0"/>
+        </a:xfrm>
+      </p:grpSpPr>
+      <p:sp>
+        <p:nvSpPr>
+          <p:cNvPr id="2" name="Title 1">
+            <a:extLst>
+              <a:ext uri="{FF2B5EF4-FFF2-40B4-BE49-F238E27FC236}">
+                <a16:creationId xmlns:a16="http://schemas.microsoft.com/office/drawing/2014/main" id="{86E81724-3991-44F2-BA6F-17C60556411D}"/>
+              </a:ext>
+            </a:extLst>
+          </p:cNvPr>
+          <p:cNvSpPr>
+            <a:spLocks noGrp="1"/>
+          </p:cNvSpPr>
+          <p:nvPr>
+            <p:ph type="title"/>
+          </p:nvPr>
+        </p:nvSpPr>
+        <p:spPr/>
+        <p:txBody>
+          <a:bodyPr/>
+          <a:lstStyle/>
+          <a:p>
+            <a:r>
+              <a:rPr lang="en-US" dirty="0"/>
+              <a:t>Assignments</a:t>
+            </a:r>
+            <a:endParaRPr lang="en-CA" dirty="0"/>
+          </a:p>
+        </p:txBody>
+      </p:sp>
+      <p:sp>
+        <p:nvSpPr>
+          <p:cNvPr id="3" name="Content Placeholder 2">
+            <a:extLst>
+              <a:ext uri="{FF2B5EF4-FFF2-40B4-BE49-F238E27FC236}">
+                <a16:creationId xmlns:a16="http://schemas.microsoft.com/office/drawing/2014/main" id="{C089213F-51D7-4BCB-A34A-8DD62577C5B9}"/>
+              </a:ext>
+            </a:extLst>
+          </p:cNvPr>
+          <p:cNvSpPr>
+            <a:spLocks noGrp="1"/>
+          </p:cNvSpPr>
+          <p:nvPr>
+            <p:ph idx="1"/>
+          </p:nvPr>
+        </p:nvSpPr>
+        <p:spPr/>
+        <p:txBody>
+          <a:bodyPr/>
+          <a:lstStyle/>
+          <a:p>
+            <a:r>
+              <a:rPr lang="en-US" dirty="0"/>
+              <a:t>2 assignments throughout the semester, completed individually.</a:t>
+            </a:r>
+          </a:p>
+        </p:txBody>
+      </p:sp>
+    </p:spTree>
+    <p:extLst>
+      <p:ext uri="{BB962C8B-B14F-4D97-AF65-F5344CB8AC3E}">
+        <p14:creationId xmlns:p14="http://schemas.microsoft.com/office/powerpoint/2010/main" val="898080511"/>
+      </p:ext>
+    </p:extLst>
+  </p:cSld>
+  <p:clrMapOvr>
+    <a:masterClrMapping/>
+  </p:clrMapOvr>
+</p:sld>
+</file>
+
+<file path=ppt/slides/slide18.xml><?xml version="1.0" encoding="utf-8"?>
+<p:sld xmlns:a="http://schemas.openxmlformats.org/drawingml/2006/main" xmlns:r="http://schemas.openxmlformats.org/officeDocument/2006/relationships" xmlns:p="http://schemas.openxmlformats.org/presentationml/2006/main">
+  <p:cSld>
+    <p:spTree>
+      <p:nvGrpSpPr>
+        <p:cNvPr id="1" name=""/>
+        <p:cNvGrpSpPr/>
+        <p:nvPr/>
+      </p:nvGrpSpPr>
+      <p:grpSpPr>
+        <a:xfrm>
+          <a:off x="0" y="0"/>
+          <a:ext cx="0" cy="0"/>
+          <a:chOff x="0" y="0"/>
+          <a:chExt cx="0" cy="0"/>
+        </a:xfrm>
+      </p:grpSpPr>
+      <p:sp>
+        <p:nvSpPr>
+          <p:cNvPr id="2" name="Title 1">
+            <a:extLst>
+              <a:ext uri="{FF2B5EF4-FFF2-40B4-BE49-F238E27FC236}">
+                <a16:creationId xmlns:a16="http://schemas.microsoft.com/office/drawing/2014/main" id="{D362A507-388C-48D4-A149-8F6BF0349009}"/>
+              </a:ext>
+            </a:extLst>
+          </p:cNvPr>
+          <p:cNvSpPr>
+            <a:spLocks noGrp="1"/>
+          </p:cNvSpPr>
+          <p:nvPr>
+            <p:ph type="title"/>
+          </p:nvPr>
+        </p:nvSpPr>
+        <p:spPr/>
+        <p:txBody>
+          <a:bodyPr/>
+          <a:lstStyle/>
+          <a:p>
+            <a:r>
+              <a:rPr lang="en-US" dirty="0"/>
+              <a:t>Labs</a:t>
+            </a:r>
+            <a:endParaRPr lang="en-CA" dirty="0"/>
+          </a:p>
+        </p:txBody>
+      </p:sp>
+      <p:sp>
+        <p:nvSpPr>
+          <p:cNvPr id="3" name="Content Placeholder 2">
+            <a:extLst>
+              <a:ext uri="{FF2B5EF4-FFF2-40B4-BE49-F238E27FC236}">
+                <a16:creationId xmlns:a16="http://schemas.microsoft.com/office/drawing/2014/main" id="{23978C3C-3E92-44F2-A9DF-D38084B9FBD4}"/>
+              </a:ext>
+            </a:extLst>
+          </p:cNvPr>
+          <p:cNvSpPr>
+            <a:spLocks noGrp="1"/>
+          </p:cNvSpPr>
+          <p:nvPr>
+            <p:ph idx="1"/>
+          </p:nvPr>
+        </p:nvSpPr>
+        <p:spPr/>
+        <p:txBody>
+          <a:bodyPr/>
+          <a:lstStyle/>
+          <a:p>
+            <a:r>
+              <a:rPr lang="en-US" dirty="0"/>
+              <a:t>Labs were previously run on everyone's computers.</a:t>
+            </a:r>
+          </a:p>
+          <a:p>
+            <a:endParaRPr lang="en-US" dirty="0"/>
+          </a:p>
+          <a:p>
+            <a:r>
+              <a:rPr lang="en-US" dirty="0"/>
+              <a:t>Labs will be in the normal “lab room” and involve some hands-on material/tools, some computer-based labs.</a:t>
+            </a:r>
+          </a:p>
+          <a:p>
+            <a:endParaRPr lang="en-CA" dirty="0"/>
+          </a:p>
+          <a:p>
+            <a:r>
+              <a:rPr lang="en-CA" dirty="0"/>
+              <a:t>Labs can be completed on your own time as well – especially computer-based ones.</a:t>
+            </a:r>
+          </a:p>
+        </p:txBody>
+      </p:sp>
+    </p:spTree>
+    <p:extLst>
+      <p:ext uri="{BB962C8B-B14F-4D97-AF65-F5344CB8AC3E}">
+        <p14:creationId xmlns:p14="http://schemas.microsoft.com/office/powerpoint/2010/main" val="3070855699"/>
+      </p:ext>
+    </p:extLst>
+  </p:cSld>
+  <p:clrMapOvr>
+    <a:masterClrMapping/>
+  </p:clrMapOvr>
+  <p:timing>
+    <p:tnLst>
+      <p:par>
+        <p:cTn id="1" dur="indefinite" restart="never" nodeType="tmRoot">
+          <p:childTnLst>
+            <p:seq concurrent="1" nextAc="seek">
+              <p:cTn id="2" dur="indefinite" nodeType="mainSeq">
+                <p:childTnLst>
+                  <p:par>
+                    <p:cTn id="3" fill="hold">
+                      <p:stCondLst>
+                        <p:cond delay="indefinite"/>
+                      </p:stCondLst>
+                      <p:childTnLst>
+                        <p:par>
+                          <p:cTn id="4" fill="hold">
+                            <p:stCondLst>
+                              <p:cond delay="0"/>
+                            </p:stCondLst>
+                            <p:childTnLst>
+                              <p:par>
+                                <p:cTn id="5" presetID="1" presetClass="entr" presetSubtype="0" fill="hold" grpId="0" nodeType="clickEffect">
+                                  <p:stCondLst>
+                                    <p:cond delay="0"/>
+                                  </p:stCondLst>
+                                  <p:childTnLst>
+                                    <p:set>
+                                      <p:cBhvr>
+                                        <p:cTn id="6" dur="1" fill="hold">
+                                          <p:stCondLst>
+                                            <p:cond delay="0"/>
+                                          </p:stCondLst>
+                                        </p:cTn>
+                                        <p:tgtEl>
+                                          <p:spTgt spid="3">
+                                            <p:txEl>
+                                              <p:pRg st="0" end="0"/>
+                                            </p:txEl>
+                                          </p:spTgt>
+                                        </p:tgtEl>
+                                        <p:attrNameLst>
+                                          <p:attrName>style.visibility</p:attrName>
+                                        </p:attrNameLst>
+                                      </p:cBhvr>
+                                      <p:to>
+                                        <p:strVal val="visible"/>
+                                      </p:to>
+                                    </p:set>
+                                  </p:childTnLst>
+                                </p:cTn>
+                              </p:par>
+                            </p:childTnLst>
+                          </p:cTn>
+                        </p:par>
+                      </p:childTnLst>
+                    </p:cTn>
+                  </p:par>
+                  <p:par>
+                    <p:cTn id="7" fill="hold">
+                      <p:stCondLst>
+                        <p:cond delay="indefinite"/>
+                      </p:stCondLst>
+                      <p:childTnLst>
+                        <p:par>
+                          <p:cTn id="8" fill="hold">
+                            <p:stCondLst>
+                              <p:cond delay="0"/>
+                            </p:stCondLst>
+                            <p:childTnLst>
+                              <p:par>
+                                <p:cTn id="9" presetID="1" presetClass="entr" presetSubtype="0" fill="hold" grpId="0" nodeType="clickEffect">
+                                  <p:stCondLst>
+                                    <p:cond delay="0"/>
+                                  </p:stCondLst>
+                                  <p:childTnLst>
+                                    <p:set>
+                                      <p:cBhvr>
+                                        <p:cTn id="10" dur="1" fill="hold">
+                                          <p:stCondLst>
+                                            <p:cond delay="0"/>
+                                          </p:stCondLst>
+                                        </p:cTn>
+                                        <p:tgtEl>
+                                          <p:spTgt spid="3">
+                                            <p:txEl>
+                                              <p:pRg st="2" end="2"/>
+                                            </p:txEl>
+                                          </p:spTgt>
+                                        </p:tgtEl>
+                                        <p:attrNameLst>
+                                          <p:attrName>style.visibility</p:attrName>
+                                        </p:attrNameLst>
+                                      </p:cBhvr>
+                                      <p:to>
+                                        <p:strVal val="visible"/>
+                                      </p:to>
+                                    </p:set>
+                                  </p:childTnLst>
+                                </p:cTn>
+                              </p:par>
+                            </p:childTnLst>
+                          </p:cTn>
+                        </p:par>
+                      </p:childTnLst>
+                    </p:cTn>
+                  </p:par>
+                  <p:par>
+                    <p:cTn id="11" fill="hold">
+                      <p:stCondLst>
+                        <p:cond delay="indefinite"/>
+                      </p:stCondLst>
+                      <p:childTnLst>
+                        <p:par>
+                          <p:cTn id="12" fill="hold">
+                            <p:stCondLst>
+                              <p:cond delay="0"/>
+                            </p:stCondLst>
+                            <p:childTnLst>
+                              <p:par>
+                                <p:cTn id="13" presetID="1" presetClass="entr" presetSubtype="0" fill="hold" grpId="0" nodeType="clickEffect">
+                                  <p:stCondLst>
+                                    <p:cond delay="0"/>
+                                  </p:stCondLst>
+                                  <p:childTnLst>
+                                    <p:set>
+                                      <p:cBhvr>
+                                        <p:cTn id="14" dur="1" fill="hold">
+                                          <p:stCondLst>
+                                            <p:cond delay="0"/>
+                                          </p:stCondLst>
+                                        </p:cTn>
+                                        <p:tgtEl>
+                                          <p:spTgt spid="3">
+                                            <p:txEl>
+                                              <p:pRg st="4" end="4"/>
+                                            </p:txEl>
+                                          </p:spTgt>
+                                        </p:tgtEl>
+                                        <p:attrNameLst>
+                                          <p:attrName>style.visibility</p:attrName>
+                                        </p:attrNameLst>
+                                      </p:cBhvr>
+                                      <p:to>
+                                        <p:strVal val="visible"/>
+                                      </p:to>
+                                    </p:set>
+                                  </p:childTnLst>
+                                </p:cTn>
+                              </p:par>
+                            </p:childTnLst>
+                          </p:cTn>
+                        </p:par>
+                      </p:childTnLst>
+                    </p:cTn>
+                  </p:par>
+                </p:childTnLst>
+              </p:cTn>
+              <p:prevCondLst>
+                <p:cond evt="onPrev" delay="0">
+                  <p:tgtEl>
+                    <p:sldTgt/>
+                  </p:tgtEl>
+                </p:cond>
+              </p:prevCondLst>
+              <p:nextCondLst>
+                <p:cond evt="onNext" delay="0">
+                  <p:tgtEl>
+                    <p:sldTgt/>
+                  </p:tgtEl>
+                </p:cond>
+              </p:nextCondLst>
+            </p:seq>
+          </p:childTnLst>
+        </p:cTn>
+      </p:par>
+    </p:tnLst>
+    <p:bldLst>
+      <p:bldP spid="3" grpId="0" build="p"/>
+    </p:bldLst>
+  </p:timing>
+</p:sld>
+</file>
+
+<file path=ppt/slides/slide19.xml><?xml version="1.0" encoding="utf-8"?>
+<p:sld xmlns:a="http://schemas.openxmlformats.org/drawingml/2006/main" xmlns:r="http://schemas.openxmlformats.org/officeDocument/2006/relationships" xmlns:p="http://schemas.openxmlformats.org/presentationml/2006/main">
+  <p:cSld>
+    <p:spTree>
+      <p:nvGrpSpPr>
+        <p:cNvPr id="1" name=""/>
+        <p:cNvGrpSpPr/>
+        <p:nvPr/>
+      </p:nvGrpSpPr>
+      <p:grpSpPr>
+        <a:xfrm>
+          <a:off x="0" y="0"/>
+          <a:ext cx="0" cy="0"/>
+          <a:chOff x="0" y="0"/>
+          <a:chExt cx="0" cy="0"/>
+        </a:xfrm>
+      </p:grpSpPr>
+      <p:sp>
+        <p:nvSpPr>
+          <p:cNvPr id="2" name="Title 1">
+            <a:extLst>
+              <a:ext uri="{FF2B5EF4-FFF2-40B4-BE49-F238E27FC236}">
+                <a16:creationId xmlns:a16="http://schemas.microsoft.com/office/drawing/2014/main" id="{96F6F40C-8FCD-4ED6-9F2E-2C0694D0F515}"/>
+              </a:ext>
+            </a:extLst>
+          </p:cNvPr>
+          <p:cNvSpPr>
+            <a:spLocks noGrp="1"/>
+          </p:cNvSpPr>
+          <p:nvPr>
+            <p:ph type="title"/>
+          </p:nvPr>
+        </p:nvSpPr>
+        <p:spPr/>
+        <p:txBody>
+          <a:bodyPr/>
+          <a:lstStyle/>
+          <a:p>
+            <a:r>
+              <a:rPr lang="en-US" dirty="0"/>
+              <a:t>Course Project</a:t>
+            </a:r>
+            <a:endParaRPr lang="en-CA" dirty="0"/>
+          </a:p>
+        </p:txBody>
+      </p:sp>
+      <p:sp>
+        <p:nvSpPr>
+          <p:cNvPr id="3" name="Content Placeholder 2">
+            <a:extLst>
+              <a:ext uri="{FF2B5EF4-FFF2-40B4-BE49-F238E27FC236}">
+                <a16:creationId xmlns:a16="http://schemas.microsoft.com/office/drawing/2014/main" id="{18EAC01E-3FCC-4281-93CB-3E87F997C69F}"/>
+              </a:ext>
+            </a:extLst>
+          </p:cNvPr>
+          <p:cNvSpPr>
+            <a:spLocks noGrp="1"/>
+          </p:cNvSpPr>
+          <p:nvPr>
+            <p:ph idx="1"/>
+          </p:nvPr>
+        </p:nvSpPr>
+        <p:spPr/>
+        <p:txBody>
+          <a:bodyPr/>
+          <a:lstStyle/>
+          <a:p>
+            <a:r>
+              <a:rPr lang="en-US" dirty="0"/>
+              <a:t>Course project will be a chance to apply some of what you’ve learned in this course.</a:t>
+            </a:r>
+          </a:p>
+          <a:p>
+            <a:r>
+              <a:rPr lang="en-US" dirty="0"/>
+              <a:t>More details coming next month once you have more background on the material.</a:t>
+            </a:r>
+          </a:p>
+        </p:txBody>
+      </p:sp>
+    </p:spTree>
+    <p:extLst>
+      <p:ext uri="{BB962C8B-B14F-4D97-AF65-F5344CB8AC3E}">
+        <p14:creationId xmlns:p14="http://schemas.microsoft.com/office/powerpoint/2010/main" val="210414657"/>
+      </p:ext>
+    </p:extLst>
+  </p:cSld>
+  <p:clrMapOvr>
+    <a:masterClrMapping/>
+  </p:clrMapOvr>
+</p:sld>
+</file>
+
+<file path=ppt/slides/slide2.xml><?xml version="1.0" encoding="utf-8"?>
+<p:sld xmlns:a="http://schemas.openxmlformats.org/drawingml/2006/main" xmlns:r="http://schemas.openxmlformats.org/officeDocument/2006/relationships" xmlns:p="http://schemas.openxmlformats.org/presentationml/2006/main">
+  <p:cSld>
+    <p:spTree>
+      <p:nvGrpSpPr>
+        <p:cNvPr id="1" name=""/>
+        <p:cNvGrpSpPr/>
+        <p:nvPr/>
+      </p:nvGrpSpPr>
+      <p:grpSpPr>
+        <a:xfrm>
+          <a:off x="0" y="0"/>
+          <a:ext cx="0" cy="0"/>
+          <a:chOff x="0" y="0"/>
+          <a:chExt cx="0" cy="0"/>
+        </a:xfrm>
+      </p:grpSpPr>
+      <p:sp>
+        <p:nvSpPr>
+          <p:cNvPr id="2" name="Title 1">
+            <a:extLst>
+              <a:ext uri="{FF2B5EF4-FFF2-40B4-BE49-F238E27FC236}">
+                <a16:creationId xmlns:a16="http://schemas.microsoft.com/office/drawing/2014/main" id="{B73A0D20-9C5B-8C57-AC08-F638A09503E5}"/>
+              </a:ext>
+            </a:extLst>
+          </p:cNvPr>
+          <p:cNvSpPr>
+            <a:spLocks noGrp="1"/>
+          </p:cNvSpPr>
+          <p:nvPr>
+            <p:ph type="title"/>
+          </p:nvPr>
+        </p:nvSpPr>
+        <p:spPr/>
+        <p:txBody>
+          <a:bodyPr/>
+          <a:lstStyle/>
+          <a:p>
+            <a:r>
+              <a:rPr lang="en-CA" b="1" u="sng" dirty="0"/>
+              <a:t>Recording Warning</a:t>
+            </a:r>
+          </a:p>
+        </p:txBody>
+      </p:sp>
+      <p:sp>
+        <p:nvSpPr>
+          <p:cNvPr id="3" name="Content Placeholder 2">
+            <a:extLst>
+              <a:ext uri="{FF2B5EF4-FFF2-40B4-BE49-F238E27FC236}">
+                <a16:creationId xmlns:a16="http://schemas.microsoft.com/office/drawing/2014/main" id="{2726E36C-54F4-98E1-4884-AF45CC424F1E}"/>
+              </a:ext>
+            </a:extLst>
+          </p:cNvPr>
+          <p:cNvSpPr>
+            <a:spLocks noGrp="1"/>
+          </p:cNvSpPr>
+          <p:nvPr>
+            <p:ph idx="1"/>
+          </p:nvPr>
+        </p:nvSpPr>
+        <p:spPr/>
+        <p:txBody>
+          <a:bodyPr/>
+          <a:lstStyle/>
+          <a:p>
+            <a:pPr marL="0" indent="0">
+              <a:buNone/>
+            </a:pPr>
+            <a:r>
+              <a:rPr lang="en-CA" dirty="0"/>
+              <a:t>Audio recording will be in use – I’ll let you know when it’s on &amp; off. You can ask for it to be paused to ask questions if you wish. I’ll always provide time before &amp; after the lecture content where unrecorded questions can be asked.</a:t>
+            </a:r>
+          </a:p>
+        </p:txBody>
+      </p:sp>
+    </p:spTree>
+    <p:extLst>
+      <p:ext uri="{BB962C8B-B14F-4D97-AF65-F5344CB8AC3E}">
+        <p14:creationId xmlns:p14="http://schemas.microsoft.com/office/powerpoint/2010/main" val="3373489935"/>
+      </p:ext>
+    </p:extLst>
+  </p:cSld>
+  <p:clrMapOvr>
+    <a:masterClrMapping/>
+  </p:clrMapOvr>
+</p:sld>
+</file>
+
+<file path=ppt/slides/slide20.xml><?xml version="1.0" encoding="utf-8"?>
+<p:sld xmlns:a="http://schemas.openxmlformats.org/drawingml/2006/main" xmlns:r="http://schemas.openxmlformats.org/officeDocument/2006/relationships" xmlns:p="http://schemas.openxmlformats.org/presentationml/2006/main">
+  <p:cSld>
+    <p:spTree>
+      <p:nvGrpSpPr>
+        <p:cNvPr id="1" name=""/>
+        <p:cNvGrpSpPr/>
+        <p:nvPr/>
+      </p:nvGrpSpPr>
+      <p:grpSpPr>
+        <a:xfrm>
+          <a:off x="0" y="0"/>
+          <a:ext cx="0" cy="0"/>
+          <a:chOff x="0" y="0"/>
+          <a:chExt cx="0" cy="0"/>
+        </a:xfrm>
+      </p:grpSpPr>
+      <p:sp>
+        <p:nvSpPr>
+          <p:cNvPr id="2" name="Title 1">
+            <a:extLst>
+              <a:ext uri="{FF2B5EF4-FFF2-40B4-BE49-F238E27FC236}">
                 <a16:creationId xmlns:a16="http://schemas.microsoft.com/office/drawing/2014/main" id="{32042985-73F7-4CE6-99CD-E2E5E21FDA3A}"/>
               </a:ext>
             </a:extLst>
@@ -3843,6 +5569,12 @@
           </a:p>
           <a:p>
             <a:endParaRPr lang="en-US" dirty="0"/>
+          </a:p>
+          <a:p>
+            <a:r>
+              <a:rPr lang="en-US" dirty="0"/>
+              <a:t>The lab exam is easy – if you personally can complete all the labs in the course, you shouldn’t have too much trouble.</a:t>
+            </a:r>
           </a:p>
           <a:p>
             <a:endParaRPr lang="en-CA" dirty="0"/>
@@ -3862,7 +5594,548 @@
 </p:sld>
 </file>
 
-<file path=ppt/slides/slide2.xml><?xml version="1.0" encoding="utf-8"?>
+<file path=ppt/slides/slide21.xml><?xml version="1.0" encoding="utf-8"?>
+<p:sld xmlns:a="http://schemas.openxmlformats.org/drawingml/2006/main" xmlns:r="http://schemas.openxmlformats.org/officeDocument/2006/relationships" xmlns:p="http://schemas.openxmlformats.org/presentationml/2006/main">
+  <p:cSld>
+    <p:spTree>
+      <p:nvGrpSpPr>
+        <p:cNvPr id="1" name=""/>
+        <p:cNvGrpSpPr/>
+        <p:nvPr/>
+      </p:nvGrpSpPr>
+      <p:grpSpPr>
+        <a:xfrm>
+          <a:off x="0" y="0"/>
+          <a:ext cx="0" cy="0"/>
+          <a:chOff x="0" y="0"/>
+          <a:chExt cx="0" cy="0"/>
+        </a:xfrm>
+      </p:grpSpPr>
+      <p:sp>
+        <p:nvSpPr>
+          <p:cNvPr id="2" name="Title 1">
+            <a:extLst>
+              <a:ext uri="{FF2B5EF4-FFF2-40B4-BE49-F238E27FC236}">
+                <a16:creationId xmlns:a16="http://schemas.microsoft.com/office/drawing/2014/main" id="{75E49DEF-91E3-A64E-0512-5C0D01531F4D}"/>
+              </a:ext>
+            </a:extLst>
+          </p:cNvPr>
+          <p:cNvSpPr>
+            <a:spLocks noGrp="1"/>
+          </p:cNvSpPr>
+          <p:nvPr>
+            <p:ph type="title"/>
+          </p:nvPr>
+        </p:nvSpPr>
+        <p:spPr/>
+        <p:txBody>
+          <a:bodyPr/>
+          <a:lstStyle/>
+          <a:p>
+            <a:r>
+              <a:rPr lang="en-CA" dirty="0"/>
+              <a:t>Notes on Quizzes, AI, and Final Exam(s)</a:t>
+            </a:r>
+          </a:p>
+        </p:txBody>
+      </p:sp>
+      <p:sp>
+        <p:nvSpPr>
+          <p:cNvPr id="3" name="Content Placeholder 2">
+            <a:extLst>
+              <a:ext uri="{FF2B5EF4-FFF2-40B4-BE49-F238E27FC236}">
+                <a16:creationId xmlns:a16="http://schemas.microsoft.com/office/drawing/2014/main" id="{6C3B0445-8E6B-EAEB-8613-28F1EA3EF4F5}"/>
+              </a:ext>
+            </a:extLst>
+          </p:cNvPr>
+          <p:cNvSpPr>
+            <a:spLocks noGrp="1"/>
+          </p:cNvSpPr>
+          <p:nvPr>
+            <p:ph idx="1"/>
+          </p:nvPr>
+        </p:nvSpPr>
+        <p:spPr/>
+        <p:txBody>
+          <a:bodyPr>
+            <a:normAutofit lnSpcReduction="10000"/>
+          </a:bodyPr>
+          <a:lstStyle/>
+          <a:p>
+            <a:r>
+              <a:rPr lang="en-CA" dirty="0"/>
+              <a:t>I follow Dalhousie’s AI policy – work submitted should be your own (see syllabus for full statement).</a:t>
+            </a:r>
+          </a:p>
+          <a:p>
+            <a:pPr marL="0" indent="0">
+              <a:buNone/>
+            </a:pPr>
+            <a:endParaRPr lang="en-CA" dirty="0"/>
+          </a:p>
+          <a:p>
+            <a:r>
+              <a:rPr lang="en-CA" dirty="0"/>
+              <a:t>AI / LLM can be a </a:t>
+            </a:r>
+            <a:r>
+              <a:rPr lang="en-CA" u="sng" dirty="0"/>
+              <a:t>very useful</a:t>
+            </a:r>
+            <a:r>
+              <a:rPr lang="en-CA" dirty="0"/>
+              <a:t> tool – it has limitations and I’ll be showing you some of these as part of the class. Understanding </a:t>
+            </a:r>
+            <a:r>
+              <a:rPr lang="en-CA" u="sng" dirty="0"/>
+              <a:t>how</a:t>
+            </a:r>
+            <a:r>
+              <a:rPr lang="en-CA" dirty="0"/>
+              <a:t> to use a tool and </a:t>
+            </a:r>
+            <a:r>
+              <a:rPr lang="en-CA" u="sng" dirty="0"/>
+              <a:t>when/where</a:t>
+            </a:r>
+            <a:r>
+              <a:rPr lang="en-CA" dirty="0"/>
+              <a:t> to use it is a core part of engineering.</a:t>
+            </a:r>
+          </a:p>
+          <a:p>
+            <a:pPr marL="0" indent="0">
+              <a:buNone/>
+            </a:pPr>
+            <a:endParaRPr lang="en-CA" dirty="0"/>
+          </a:p>
+          <a:p>
+            <a:r>
+              <a:rPr lang="en-CA" dirty="0"/>
+              <a:t>I use the Final Exam as a validation of your personal knowledge – if you have completed assignments/labs yourself you’ll find them easy, if using AI to complete assignments you’ll find them difficult.</a:t>
+            </a:r>
+          </a:p>
+        </p:txBody>
+      </p:sp>
+      <p:sp>
+        <p:nvSpPr>
+          <p:cNvPr id="4" name="Footer Placeholder 3">
+            <a:extLst>
+              <a:ext uri="{FF2B5EF4-FFF2-40B4-BE49-F238E27FC236}">
+                <a16:creationId xmlns:a16="http://schemas.microsoft.com/office/drawing/2014/main" id="{8561CBB3-7438-E895-8E9A-C023A5FC3046}"/>
+              </a:ext>
+            </a:extLst>
+          </p:cNvPr>
+          <p:cNvSpPr>
+            <a:spLocks noGrp="1"/>
+          </p:cNvSpPr>
+          <p:nvPr>
+            <p:ph type="ftr" sz="quarter" idx="11"/>
+          </p:nvPr>
+        </p:nvSpPr>
+        <p:spPr/>
+        <p:txBody>
+          <a:bodyPr/>
+          <a:lstStyle/>
+          <a:p>
+            <a:r>
+              <a:rPr lang="en-US"/>
+              <a:t>ECED3403 Computer Architecture. Colin O'Flynn.</a:t>
+            </a:r>
+            <a:endParaRPr lang="en-CA"/>
+          </a:p>
+        </p:txBody>
+      </p:sp>
+      <p:sp>
+        <p:nvSpPr>
+          <p:cNvPr id="5" name="Date Placeholder 4">
+            <a:extLst>
+              <a:ext uri="{FF2B5EF4-FFF2-40B4-BE49-F238E27FC236}">
+                <a16:creationId xmlns:a16="http://schemas.microsoft.com/office/drawing/2014/main" id="{591E8461-E694-A985-BB1D-A75319D4EBFD}"/>
+              </a:ext>
+            </a:extLst>
+          </p:cNvPr>
+          <p:cNvSpPr>
+            <a:spLocks noGrp="1"/>
+          </p:cNvSpPr>
+          <p:nvPr>
+            <p:ph type="dt" sz="half" idx="10"/>
+          </p:nvPr>
+        </p:nvSpPr>
+        <p:spPr/>
+        <p:txBody>
+          <a:bodyPr/>
+          <a:lstStyle/>
+          <a:p>
+            <a:r>
+              <a:rPr lang="en-CA"/>
+              <a:t>Last Update: 2026-01-06</a:t>
+            </a:r>
+          </a:p>
+        </p:txBody>
+      </p:sp>
+    </p:spTree>
+    <p:extLst>
+      <p:ext uri="{BB962C8B-B14F-4D97-AF65-F5344CB8AC3E}">
+        <p14:creationId xmlns:p14="http://schemas.microsoft.com/office/powerpoint/2010/main" val="3747015805"/>
+      </p:ext>
+    </p:extLst>
+  </p:cSld>
+  <p:clrMapOvr>
+    <a:masterClrMapping/>
+  </p:clrMapOvr>
+</p:sld>
+</file>
+
+<file path=ppt/slides/slide22.xml><?xml version="1.0" encoding="utf-8"?>
+<p:sld xmlns:a="http://schemas.openxmlformats.org/drawingml/2006/main" xmlns:r="http://schemas.openxmlformats.org/officeDocument/2006/relationships" xmlns:p="http://schemas.openxmlformats.org/presentationml/2006/main">
+  <p:cSld>
+    <p:spTree>
+      <p:nvGrpSpPr>
+        <p:cNvPr id="1" name=""/>
+        <p:cNvGrpSpPr/>
+        <p:nvPr/>
+      </p:nvGrpSpPr>
+      <p:grpSpPr>
+        <a:xfrm>
+          <a:off x="0" y="0"/>
+          <a:ext cx="0" cy="0"/>
+          <a:chOff x="0" y="0"/>
+          <a:chExt cx="0" cy="0"/>
+        </a:xfrm>
+      </p:grpSpPr>
+      <p:sp>
+        <p:nvSpPr>
+          <p:cNvPr id="2" name="Title 1">
+            <a:extLst>
+              <a:ext uri="{FF2B5EF4-FFF2-40B4-BE49-F238E27FC236}">
+                <a16:creationId xmlns:a16="http://schemas.microsoft.com/office/drawing/2014/main" id="{273719AF-9823-F117-3E2D-37A2588CE0E4}"/>
+              </a:ext>
+            </a:extLst>
+          </p:cNvPr>
+          <p:cNvSpPr>
+            <a:spLocks noGrp="1"/>
+          </p:cNvSpPr>
+          <p:nvPr>
+            <p:ph type="title"/>
+          </p:nvPr>
+        </p:nvSpPr>
+        <p:spPr/>
+        <p:txBody>
+          <a:bodyPr/>
+          <a:lstStyle/>
+          <a:p>
+            <a:r>
+              <a:rPr lang="en-CA" dirty="0"/>
+              <a:t>Course Questions For Me</a:t>
+            </a:r>
+          </a:p>
+        </p:txBody>
+      </p:sp>
+      <p:sp>
+        <p:nvSpPr>
+          <p:cNvPr id="3" name="Content Placeholder 2">
+            <a:extLst>
+              <a:ext uri="{FF2B5EF4-FFF2-40B4-BE49-F238E27FC236}">
+                <a16:creationId xmlns:a16="http://schemas.microsoft.com/office/drawing/2014/main" id="{C247DDED-A245-2CF5-7D3F-0501441DCA62}"/>
+              </a:ext>
+            </a:extLst>
+          </p:cNvPr>
+          <p:cNvSpPr>
+            <a:spLocks noGrp="1"/>
+          </p:cNvSpPr>
+          <p:nvPr>
+            <p:ph idx="1"/>
+          </p:nvPr>
+        </p:nvSpPr>
+        <p:spPr/>
+        <p:txBody>
+          <a:bodyPr/>
+          <a:lstStyle/>
+          <a:p>
+            <a:pPr marL="0" indent="0" algn="ctr">
+              <a:buNone/>
+            </a:pPr>
+            <a:endParaRPr lang="en-CA" dirty="0"/>
+          </a:p>
+          <a:p>
+            <a:pPr marL="0" indent="0" algn="ctr">
+              <a:buNone/>
+            </a:pPr>
+            <a:r>
+              <a:rPr lang="en-CA" dirty="0"/>
+              <a:t>Questions or Concerns?</a:t>
+            </a:r>
+          </a:p>
+          <a:p>
+            <a:pPr marL="0" indent="0" algn="ctr">
+              <a:buNone/>
+            </a:pPr>
+            <a:endParaRPr lang="en-CA" dirty="0"/>
+          </a:p>
+          <a:p>
+            <a:pPr marL="0" indent="0" algn="ctr">
+              <a:buNone/>
+            </a:pPr>
+            <a:r>
+              <a:rPr lang="en-CA" dirty="0"/>
+              <a:t>coflynn@dal.ca</a:t>
+            </a:r>
+          </a:p>
+          <a:p>
+            <a:pPr marL="0" indent="0" algn="ctr">
+              <a:buNone/>
+            </a:pPr>
+            <a:endParaRPr lang="en-CA" dirty="0"/>
+          </a:p>
+          <a:p>
+            <a:pPr marL="0" indent="0" algn="ctr">
+              <a:buNone/>
+            </a:pPr>
+            <a:r>
+              <a:rPr lang="en-CA" dirty="0"/>
+              <a:t>If not we’ll pick this up on the first “normal” lecture day to introduce the first topic.</a:t>
+            </a:r>
+          </a:p>
+        </p:txBody>
+      </p:sp>
+      <p:sp>
+        <p:nvSpPr>
+          <p:cNvPr id="4" name="Footer Placeholder 3">
+            <a:extLst>
+              <a:ext uri="{FF2B5EF4-FFF2-40B4-BE49-F238E27FC236}">
+                <a16:creationId xmlns:a16="http://schemas.microsoft.com/office/drawing/2014/main" id="{AB014885-9A2D-8F61-833E-985DBF64BD11}"/>
+              </a:ext>
+            </a:extLst>
+          </p:cNvPr>
+          <p:cNvSpPr>
+            <a:spLocks noGrp="1"/>
+          </p:cNvSpPr>
+          <p:nvPr>
+            <p:ph type="ftr" sz="quarter" idx="11"/>
+          </p:nvPr>
+        </p:nvSpPr>
+        <p:spPr/>
+        <p:txBody>
+          <a:bodyPr/>
+          <a:lstStyle/>
+          <a:p>
+            <a:r>
+              <a:rPr lang="en-US"/>
+              <a:t>ECED3403 Computer Architecture. Colin O'Flynn.</a:t>
+            </a:r>
+            <a:endParaRPr lang="en-CA"/>
+          </a:p>
+        </p:txBody>
+      </p:sp>
+      <p:sp>
+        <p:nvSpPr>
+          <p:cNvPr id="5" name="Date Placeholder 4">
+            <a:extLst>
+              <a:ext uri="{FF2B5EF4-FFF2-40B4-BE49-F238E27FC236}">
+                <a16:creationId xmlns:a16="http://schemas.microsoft.com/office/drawing/2014/main" id="{1892F4B6-76EC-94E7-4DD5-0A9E1FB9E9CF}"/>
+              </a:ext>
+            </a:extLst>
+          </p:cNvPr>
+          <p:cNvSpPr>
+            <a:spLocks noGrp="1"/>
+          </p:cNvSpPr>
+          <p:nvPr>
+            <p:ph type="dt" sz="half" idx="10"/>
+          </p:nvPr>
+        </p:nvSpPr>
+        <p:spPr/>
+        <p:txBody>
+          <a:bodyPr/>
+          <a:lstStyle/>
+          <a:p>
+            <a:r>
+              <a:rPr lang="en-CA" dirty="0"/>
+              <a:t>Last Update: 2026-01-08</a:t>
+            </a:r>
+          </a:p>
+        </p:txBody>
+      </p:sp>
+    </p:spTree>
+    <p:extLst>
+      <p:ext uri="{BB962C8B-B14F-4D97-AF65-F5344CB8AC3E}">
+        <p14:creationId xmlns:p14="http://schemas.microsoft.com/office/powerpoint/2010/main" val="564549306"/>
+      </p:ext>
+    </p:extLst>
+  </p:cSld>
+  <p:clrMapOvr>
+    <a:masterClrMapping/>
+  </p:clrMapOvr>
+</p:sld>
+</file>
+
+<file path=ppt/slides/slide3.xml><?xml version="1.0" encoding="utf-8"?>
+<p:sld xmlns:a="http://schemas.openxmlformats.org/drawingml/2006/main" xmlns:r="http://schemas.openxmlformats.org/officeDocument/2006/relationships" xmlns:p="http://schemas.openxmlformats.org/presentationml/2006/main">
+  <p:cSld>
+    <p:spTree>
+      <p:nvGrpSpPr>
+        <p:cNvPr id="1" name=""/>
+        <p:cNvGrpSpPr/>
+        <p:nvPr/>
+      </p:nvGrpSpPr>
+      <p:grpSpPr>
+        <a:xfrm>
+          <a:off x="0" y="0"/>
+          <a:ext cx="0" cy="0"/>
+          <a:chOff x="0" y="0"/>
+          <a:chExt cx="0" cy="0"/>
+        </a:xfrm>
+      </p:grpSpPr>
+      <p:sp>
+        <p:nvSpPr>
+          <p:cNvPr id="2" name="Title 1">
+            <a:extLst>
+              <a:ext uri="{FF2B5EF4-FFF2-40B4-BE49-F238E27FC236}">
+                <a16:creationId xmlns:a16="http://schemas.microsoft.com/office/drawing/2014/main" id="{01893DAE-5A15-52C8-1016-C2816BD2B35A}"/>
+              </a:ext>
+            </a:extLst>
+          </p:cNvPr>
+          <p:cNvSpPr>
+            <a:spLocks noGrp="1"/>
+          </p:cNvSpPr>
+          <p:nvPr>
+            <p:ph type="title"/>
+          </p:nvPr>
+        </p:nvSpPr>
+        <p:spPr/>
+        <p:txBody>
+          <a:bodyPr/>
+          <a:lstStyle/>
+          <a:p>
+            <a:r>
+              <a:rPr lang="en-CA" dirty="0"/>
+              <a:t>Note on Slides, Notes, and Accommodations</a:t>
+            </a:r>
+          </a:p>
+        </p:txBody>
+      </p:sp>
+      <p:sp>
+        <p:nvSpPr>
+          <p:cNvPr id="3" name="Content Placeholder 2">
+            <a:extLst>
+              <a:ext uri="{FF2B5EF4-FFF2-40B4-BE49-F238E27FC236}">
+                <a16:creationId xmlns:a16="http://schemas.microsoft.com/office/drawing/2014/main" id="{F5D82DFD-8778-F176-CBD0-0268EC138BA6}"/>
+              </a:ext>
+            </a:extLst>
+          </p:cNvPr>
+          <p:cNvSpPr>
+            <a:spLocks noGrp="1"/>
+          </p:cNvSpPr>
+          <p:nvPr>
+            <p:ph idx="1"/>
+          </p:nvPr>
+        </p:nvSpPr>
+        <p:spPr>
+          <a:xfrm>
+            <a:off x="838200" y="1690688"/>
+            <a:ext cx="10515600" cy="4351338"/>
+          </a:xfrm>
+        </p:spPr>
+        <p:txBody>
+          <a:bodyPr/>
+          <a:lstStyle/>
+          <a:p>
+            <a:r>
+              <a:rPr lang="en-CA" i="1" dirty="0"/>
+              <a:t>Slides will generally be high-contrast where possible with this simple “PowerPoint Default” design to improve recognition if using assistance technology.</a:t>
+            </a:r>
+          </a:p>
+          <a:p>
+            <a:endParaRPr lang="en-CA" i="1" dirty="0"/>
+          </a:p>
+          <a:p>
+            <a:r>
+              <a:rPr lang="en-CA" i="1" dirty="0"/>
+              <a:t>Slides will be posted before classes as PDF (sometimes I forget – just ask in class if not there!).</a:t>
+            </a:r>
+          </a:p>
+          <a:p>
+            <a:endParaRPr lang="en-CA" i="1" dirty="0"/>
+          </a:p>
+          <a:p>
+            <a:r>
+              <a:rPr lang="en-CA" i="1" dirty="0"/>
+              <a:t>Lectures are recorded and posted in Brightspace – normally right after class, if not there by end of day check in with me.</a:t>
+            </a:r>
+          </a:p>
+        </p:txBody>
+      </p:sp>
+      <p:sp>
+        <p:nvSpPr>
+          <p:cNvPr id="4" name="Date Placeholder 3">
+            <a:extLst>
+              <a:ext uri="{FF2B5EF4-FFF2-40B4-BE49-F238E27FC236}">
+                <a16:creationId xmlns:a16="http://schemas.microsoft.com/office/drawing/2014/main" id="{B3542D6D-9998-02AD-CDE4-1F4245EDAF91}"/>
+              </a:ext>
+            </a:extLst>
+          </p:cNvPr>
+          <p:cNvSpPr>
+            <a:spLocks noGrp="1"/>
+          </p:cNvSpPr>
+          <p:nvPr>
+            <p:ph type="dt" sz="half" idx="10"/>
+          </p:nvPr>
+        </p:nvSpPr>
+        <p:spPr/>
+        <p:txBody>
+          <a:bodyPr/>
+          <a:lstStyle/>
+          <a:p>
+            <a:r>
+              <a:rPr lang="en-CA"/>
+              <a:t>Last Update: 2026-01-06</a:t>
+            </a:r>
+          </a:p>
+        </p:txBody>
+      </p:sp>
+      <p:sp>
+        <p:nvSpPr>
+          <p:cNvPr id="5" name="Footer Placeholder 4">
+            <a:extLst>
+              <a:ext uri="{FF2B5EF4-FFF2-40B4-BE49-F238E27FC236}">
+                <a16:creationId xmlns:a16="http://schemas.microsoft.com/office/drawing/2014/main" id="{6AE180CA-CEA2-027F-0C9F-4653DD137874}"/>
+              </a:ext>
+            </a:extLst>
+          </p:cNvPr>
+          <p:cNvSpPr>
+            <a:spLocks noGrp="1"/>
+          </p:cNvSpPr>
+          <p:nvPr>
+            <p:ph type="ftr" sz="quarter" idx="11"/>
+          </p:nvPr>
+        </p:nvSpPr>
+        <p:spPr/>
+        <p:txBody>
+          <a:bodyPr/>
+          <a:lstStyle/>
+          <a:p>
+            <a:r>
+              <a:rPr lang="en-US"/>
+              <a:t>ECED3403 Computer Architecture. Colin O'Flynn.</a:t>
+            </a:r>
+            <a:endParaRPr lang="en-CA"/>
+          </a:p>
+        </p:txBody>
+      </p:sp>
+    </p:spTree>
+    <p:extLst>
+      <p:ext uri="{BB962C8B-B14F-4D97-AF65-F5344CB8AC3E}">
+        <p14:creationId xmlns:p14="http://schemas.microsoft.com/office/powerpoint/2010/main" val="1861557081"/>
+      </p:ext>
+    </p:extLst>
+  </p:cSld>
+  <p:clrMapOvr>
+    <a:masterClrMapping/>
+  </p:clrMapOvr>
+</p:sld>
+</file>
+
+<file path=ppt/slides/slide4.xml><?xml version="1.0" encoding="utf-8"?>
 <p:sld xmlns:a="http://schemas.openxmlformats.org/drawingml/2006/main" xmlns:r="http://schemas.openxmlformats.org/officeDocument/2006/relationships" xmlns:p="http://schemas.openxmlformats.org/presentationml/2006/main">
   <p:cSld>
     <p:spTree>
@@ -4574,7 +6847,7 @@
 </p:sld>
 </file>
 
-<file path=ppt/slides/slide3.xml><?xml version="1.0" encoding="utf-8"?>
+<file path=ppt/slides/slide5.xml><?xml version="1.0" encoding="utf-8"?>
 <p:sld xmlns:a="http://schemas.openxmlformats.org/drawingml/2006/main" xmlns:r="http://schemas.openxmlformats.org/officeDocument/2006/relationships" xmlns:p="http://schemas.openxmlformats.org/presentationml/2006/main">
   <p:cSld>
     <p:spTree>
@@ -4989,7 +7262,7 @@
 </p:sld>
 </file>
 
-<file path=ppt/slides/slide4.xml><?xml version="1.0" encoding="utf-8"?>
+<file path=ppt/slides/slide6.xml><?xml version="1.0" encoding="utf-8"?>
 <p:sld xmlns:a="http://schemas.openxmlformats.org/drawingml/2006/main" xmlns:r="http://schemas.openxmlformats.org/officeDocument/2006/relationships" xmlns:p="http://schemas.openxmlformats.org/presentationml/2006/main">
   <p:cSld>
     <p:spTree>
@@ -5354,678 +7627,6 @@
 </p:sld>
 </file>
 
-<file path=ppt/slides/slide5.xml><?xml version="1.0" encoding="utf-8"?>
-<p:sld xmlns:a="http://schemas.openxmlformats.org/drawingml/2006/main" xmlns:r="http://schemas.openxmlformats.org/officeDocument/2006/relationships" xmlns:p="http://schemas.openxmlformats.org/presentationml/2006/main">
-  <p:cSld>
-    <p:spTree>
-      <p:nvGrpSpPr>
-        <p:cNvPr id="1" name=""/>
-        <p:cNvGrpSpPr/>
-        <p:nvPr/>
-      </p:nvGrpSpPr>
-      <p:grpSpPr>
-        <a:xfrm>
-          <a:off x="0" y="0"/>
-          <a:ext cx="0" cy="0"/>
-          <a:chOff x="0" y="0"/>
-          <a:chExt cx="0" cy="0"/>
-        </a:xfrm>
-      </p:grpSpPr>
-      <p:sp>
-        <p:nvSpPr>
-          <p:cNvPr id="2" name="Title 1">
-            <a:extLst>
-              <a:ext uri="{FF2B5EF4-FFF2-40B4-BE49-F238E27FC236}">
-                <a16:creationId xmlns:a16="http://schemas.microsoft.com/office/drawing/2014/main" id="{C38C2DD5-3850-D69A-D95D-8FB4E256F259}"/>
-              </a:ext>
-            </a:extLst>
-          </p:cNvPr>
-          <p:cNvSpPr>
-            <a:spLocks noGrp="1"/>
-          </p:cNvSpPr>
-          <p:nvPr>
-            <p:ph type="title"/>
-          </p:nvPr>
-        </p:nvSpPr>
-        <p:spPr/>
-        <p:txBody>
-          <a:bodyPr/>
-          <a:lstStyle/>
-          <a:p>
-            <a:r>
-              <a:rPr lang="en-CA" dirty="0"/>
-              <a:t>Online to In Person</a:t>
-            </a:r>
-          </a:p>
-        </p:txBody>
-      </p:sp>
-      <p:sp>
-        <p:nvSpPr>
-          <p:cNvPr id="3" name="Content Placeholder 2">
-            <a:extLst>
-              <a:ext uri="{FF2B5EF4-FFF2-40B4-BE49-F238E27FC236}">
-                <a16:creationId xmlns:a16="http://schemas.microsoft.com/office/drawing/2014/main" id="{B2EB9948-0078-F848-0E56-D6EC1BE3348F}"/>
-              </a:ext>
-            </a:extLst>
-          </p:cNvPr>
-          <p:cNvSpPr>
-            <a:spLocks noGrp="1"/>
-          </p:cNvSpPr>
-          <p:nvPr>
-            <p:ph idx="1"/>
-          </p:nvPr>
-        </p:nvSpPr>
-        <p:spPr/>
-        <p:txBody>
-          <a:bodyPr/>
-          <a:lstStyle/>
-          <a:p>
-            <a:r>
-              <a:rPr lang="en-CA" dirty="0"/>
-              <a:t>I previously taught this course only online. This is the first </a:t>
-            </a:r>
-            <a:r>
-              <a:rPr lang="en-CA" u="sng" dirty="0"/>
-              <a:t>in-person</a:t>
-            </a:r>
-            <a:r>
-              <a:rPr lang="en-CA" dirty="0"/>
-              <a:t> edition.</a:t>
-            </a:r>
-          </a:p>
-          <a:p>
-            <a:r>
-              <a:rPr lang="en-CA" dirty="0"/>
-              <a:t>Previous lectures are available (from 2020 year) at </a:t>
-            </a:r>
-            <a:r>
-              <a:rPr lang="en-CA" dirty="0">
-                <a:hlinkClick r:id="rId2"/>
-              </a:rPr>
-              <a:t>https://www.youtube.com/playlist?list=PLyAXNQGte3qNNbs8J3gE8JkpAJ9_OH75q</a:t>
-            </a:r>
-            <a:r>
-              <a:rPr lang="en-CA" dirty="0"/>
-              <a:t> .</a:t>
-            </a:r>
-          </a:p>
-          <a:p>
-            <a:r>
-              <a:rPr lang="en-CA" dirty="0"/>
-              <a:t>Watch that some things (especially assignments/labs) may have changes this year.</a:t>
-            </a:r>
-          </a:p>
-          <a:p>
-            <a:r>
-              <a:rPr lang="en-CA" dirty="0"/>
-              <a:t>Where lectures differ, I’ll record versions and try to post them.</a:t>
-            </a:r>
-          </a:p>
-          <a:p>
-            <a:r>
-              <a:rPr lang="en-CA" dirty="0"/>
-              <a:t>“Lectures” were short – one class contains multiple lectures!</a:t>
-            </a:r>
-          </a:p>
-        </p:txBody>
-      </p:sp>
-    </p:spTree>
-    <p:extLst>
-      <p:ext uri="{BB962C8B-B14F-4D97-AF65-F5344CB8AC3E}">
-        <p14:creationId xmlns:p14="http://schemas.microsoft.com/office/powerpoint/2010/main" val="2482730179"/>
-      </p:ext>
-    </p:extLst>
-  </p:cSld>
-  <p:clrMapOvr>
-    <a:masterClrMapping/>
-  </p:clrMapOvr>
-</p:sld>
-</file>
-
-<file path=ppt/slides/slide6.xml><?xml version="1.0" encoding="utf-8"?>
-<p:sld xmlns:a="http://schemas.openxmlformats.org/drawingml/2006/main" xmlns:r="http://schemas.openxmlformats.org/officeDocument/2006/relationships" xmlns:p="http://schemas.openxmlformats.org/presentationml/2006/main">
-  <p:cSld>
-    <p:spTree>
-      <p:nvGrpSpPr>
-        <p:cNvPr id="1" name=""/>
-        <p:cNvGrpSpPr/>
-        <p:nvPr/>
-      </p:nvGrpSpPr>
-      <p:grpSpPr>
-        <a:xfrm>
-          <a:off x="0" y="0"/>
-          <a:ext cx="0" cy="0"/>
-          <a:chOff x="0" y="0"/>
-          <a:chExt cx="0" cy="0"/>
-        </a:xfrm>
-      </p:grpSpPr>
-      <p:sp>
-        <p:nvSpPr>
-          <p:cNvPr id="2" name="Title 1">
-            <a:extLst>
-              <a:ext uri="{FF2B5EF4-FFF2-40B4-BE49-F238E27FC236}">
-                <a16:creationId xmlns:a16="http://schemas.microsoft.com/office/drawing/2014/main" id="{505070EA-A2BA-4038-B982-862098C0430B}"/>
-              </a:ext>
-            </a:extLst>
-          </p:cNvPr>
-          <p:cNvSpPr>
-            <a:spLocks noGrp="1"/>
-          </p:cNvSpPr>
-          <p:nvPr>
-            <p:ph type="title"/>
-          </p:nvPr>
-        </p:nvSpPr>
-        <p:spPr/>
-        <p:txBody>
-          <a:bodyPr/>
-          <a:lstStyle/>
-          <a:p>
-            <a:r>
-              <a:rPr lang="en-US" dirty="0"/>
-              <a:t>Course Lecture Style</a:t>
-            </a:r>
-            <a:endParaRPr lang="en-CA" dirty="0"/>
-          </a:p>
-        </p:txBody>
-      </p:sp>
-      <p:sp>
-        <p:nvSpPr>
-          <p:cNvPr id="3" name="Content Placeholder 2">
-            <a:extLst>
-              <a:ext uri="{FF2B5EF4-FFF2-40B4-BE49-F238E27FC236}">
-                <a16:creationId xmlns:a16="http://schemas.microsoft.com/office/drawing/2014/main" id="{7A6F966A-DAE3-4AFC-AC52-05F594C5937E}"/>
-              </a:ext>
-            </a:extLst>
-          </p:cNvPr>
-          <p:cNvSpPr>
-            <a:spLocks noGrp="1"/>
-          </p:cNvSpPr>
-          <p:nvPr>
-            <p:ph idx="1"/>
-          </p:nvPr>
-        </p:nvSpPr>
-        <p:spPr>
-          <a:xfrm>
-            <a:off x="838200" y="1623848"/>
-            <a:ext cx="10515600" cy="4553115"/>
-          </a:xfrm>
-        </p:spPr>
-        <p:txBody>
-          <a:bodyPr>
-            <a:normAutofit lnSpcReduction="10000"/>
-          </a:bodyPr>
-          <a:lstStyle/>
-          <a:p>
-            <a:r>
-              <a:rPr lang="en-US" dirty="0"/>
-              <a:t>Class schedule is roughly as follows each day:</a:t>
-            </a:r>
-          </a:p>
-          <a:p>
-            <a:r>
-              <a:rPr lang="en-US" dirty="0"/>
-              <a:t>Monday @ 10:05AM – 11:25AM</a:t>
-            </a:r>
-          </a:p>
-          <a:p>
-            <a:r>
-              <a:rPr lang="en-US" dirty="0"/>
-              <a:t>Thursdays @ 10:05AM – 11:25AM</a:t>
-            </a:r>
-          </a:p>
-          <a:p>
-            <a:pPr marL="0" indent="0">
-              <a:buNone/>
-            </a:pPr>
-            <a:endParaRPr lang="en-US" dirty="0"/>
-          </a:p>
-          <a:p>
-            <a:pPr marL="0" indent="0">
-              <a:buNone/>
-            </a:pPr>
-            <a:r>
-              <a:rPr lang="en-US" dirty="0"/>
-              <a:t>Classes will </a:t>
-            </a:r>
-            <a:r>
-              <a:rPr lang="en-US" i="1" dirty="0"/>
-              <a:t>roughly</a:t>
-            </a:r>
-            <a:r>
-              <a:rPr lang="en-US" dirty="0"/>
-              <a:t> follow the schedule each day:</a:t>
-            </a:r>
-          </a:p>
-          <a:p>
-            <a:pPr marL="0" indent="0">
-              <a:buNone/>
-            </a:pPr>
-            <a:endParaRPr lang="en-US" dirty="0"/>
-          </a:p>
-          <a:p>
-            <a:pPr marL="0" indent="0">
-              <a:buNone/>
-            </a:pPr>
-            <a:r>
-              <a:rPr lang="en-US" dirty="0"/>
-              <a:t>10:05-10:15: Recap of previous lecture (possibly longer if needed).</a:t>
-            </a:r>
-          </a:p>
-          <a:p>
-            <a:pPr marL="0" indent="0">
-              <a:buNone/>
-            </a:pPr>
-            <a:r>
-              <a:rPr lang="en-US" dirty="0"/>
-              <a:t>10:15-11:00: New material / lectures (45 mins)</a:t>
-            </a:r>
-          </a:p>
-          <a:p>
-            <a:pPr marL="0" indent="0">
-              <a:buNone/>
-            </a:pPr>
-            <a:r>
-              <a:rPr lang="en-US" dirty="0"/>
-              <a:t>11:00-11:25: Questions &amp; discussions</a:t>
-            </a:r>
-          </a:p>
-          <a:p>
-            <a:pPr marL="0" indent="0">
-              <a:buNone/>
-            </a:pPr>
-            <a:endParaRPr lang="en-US" dirty="0"/>
-          </a:p>
-        </p:txBody>
-      </p:sp>
-    </p:spTree>
-    <p:extLst>
-      <p:ext uri="{BB962C8B-B14F-4D97-AF65-F5344CB8AC3E}">
-        <p14:creationId xmlns:p14="http://schemas.microsoft.com/office/powerpoint/2010/main" val="519975281"/>
-      </p:ext>
-    </p:extLst>
-  </p:cSld>
-  <p:clrMapOvr>
-    <a:masterClrMapping/>
-  </p:clrMapOvr>
-  <p:timing>
-    <p:tnLst>
-      <p:par>
-        <p:cTn id="1" dur="indefinite" restart="never" nodeType="tmRoot">
-          <p:childTnLst>
-            <p:seq concurrent="1" nextAc="seek">
-              <p:cTn id="2" dur="indefinite" nodeType="mainSeq">
-                <p:childTnLst>
-                  <p:par>
-                    <p:cTn id="3" fill="hold">
-                      <p:stCondLst>
-                        <p:cond delay="indefinite"/>
-                      </p:stCondLst>
-                      <p:childTnLst>
-                        <p:par>
-                          <p:cTn id="4" fill="hold">
-                            <p:stCondLst>
-                              <p:cond delay="0"/>
-                            </p:stCondLst>
-                            <p:childTnLst>
-                              <p:par>
-                                <p:cTn id="5" presetID="1" presetClass="entr" presetSubtype="0" fill="hold" grpId="0" nodeType="clickEffect">
-                                  <p:stCondLst>
-                                    <p:cond delay="0"/>
-                                  </p:stCondLst>
-                                  <p:childTnLst>
-                                    <p:set>
-                                      <p:cBhvr>
-                                        <p:cTn id="6" dur="1" fill="hold">
-                                          <p:stCondLst>
-                                            <p:cond delay="0"/>
-                                          </p:stCondLst>
-                                        </p:cTn>
-                                        <p:tgtEl>
-                                          <p:spTgt spid="3">
-                                            <p:txEl>
-                                              <p:pRg st="0" end="0"/>
-                                            </p:txEl>
-                                          </p:spTgt>
-                                        </p:tgtEl>
-                                        <p:attrNameLst>
-                                          <p:attrName>style.visibility</p:attrName>
-                                        </p:attrNameLst>
-                                      </p:cBhvr>
-                                      <p:to>
-                                        <p:strVal val="visible"/>
-                                      </p:to>
-                                    </p:set>
-                                  </p:childTnLst>
-                                </p:cTn>
-                              </p:par>
-                            </p:childTnLst>
-                          </p:cTn>
-                        </p:par>
-                      </p:childTnLst>
-                    </p:cTn>
-                  </p:par>
-                  <p:par>
-                    <p:cTn id="7" fill="hold">
-                      <p:stCondLst>
-                        <p:cond delay="indefinite"/>
-                      </p:stCondLst>
-                      <p:childTnLst>
-                        <p:par>
-                          <p:cTn id="8" fill="hold">
-                            <p:stCondLst>
-                              <p:cond delay="0"/>
-                            </p:stCondLst>
-                            <p:childTnLst>
-                              <p:par>
-                                <p:cTn id="9" presetID="1" presetClass="entr" presetSubtype="0" fill="hold" grpId="0" nodeType="clickEffect">
-                                  <p:stCondLst>
-                                    <p:cond delay="0"/>
-                                  </p:stCondLst>
-                                  <p:childTnLst>
-                                    <p:set>
-                                      <p:cBhvr>
-                                        <p:cTn id="10" dur="1" fill="hold">
-                                          <p:stCondLst>
-                                            <p:cond delay="0"/>
-                                          </p:stCondLst>
-                                        </p:cTn>
-                                        <p:tgtEl>
-                                          <p:spTgt spid="3">
-                                            <p:txEl>
-                                              <p:pRg st="1" end="1"/>
-                                            </p:txEl>
-                                          </p:spTgt>
-                                        </p:tgtEl>
-                                        <p:attrNameLst>
-                                          <p:attrName>style.visibility</p:attrName>
-                                        </p:attrNameLst>
-                                      </p:cBhvr>
-                                      <p:to>
-                                        <p:strVal val="visible"/>
-                                      </p:to>
-                                    </p:set>
-                                  </p:childTnLst>
-                                </p:cTn>
-                              </p:par>
-                            </p:childTnLst>
-                          </p:cTn>
-                        </p:par>
-                      </p:childTnLst>
-                    </p:cTn>
-                  </p:par>
-                  <p:par>
-                    <p:cTn id="11" fill="hold">
-                      <p:stCondLst>
-                        <p:cond delay="indefinite"/>
-                      </p:stCondLst>
-                      <p:childTnLst>
-                        <p:par>
-                          <p:cTn id="12" fill="hold">
-                            <p:stCondLst>
-                              <p:cond delay="0"/>
-                            </p:stCondLst>
-                            <p:childTnLst>
-                              <p:par>
-                                <p:cTn id="13" presetID="1" presetClass="entr" presetSubtype="0" fill="hold" grpId="0" nodeType="clickEffect">
-                                  <p:stCondLst>
-                                    <p:cond delay="0"/>
-                                  </p:stCondLst>
-                                  <p:childTnLst>
-                                    <p:set>
-                                      <p:cBhvr>
-                                        <p:cTn id="14" dur="1" fill="hold">
-                                          <p:stCondLst>
-                                            <p:cond delay="0"/>
-                                          </p:stCondLst>
-                                        </p:cTn>
-                                        <p:tgtEl>
-                                          <p:spTgt spid="3">
-                                            <p:txEl>
-                                              <p:pRg st="2" end="2"/>
-                                            </p:txEl>
-                                          </p:spTgt>
-                                        </p:tgtEl>
-                                        <p:attrNameLst>
-                                          <p:attrName>style.visibility</p:attrName>
-                                        </p:attrNameLst>
-                                      </p:cBhvr>
-                                      <p:to>
-                                        <p:strVal val="visible"/>
-                                      </p:to>
-                                    </p:set>
-                                  </p:childTnLst>
-                                </p:cTn>
-                              </p:par>
-                            </p:childTnLst>
-                          </p:cTn>
-                        </p:par>
-                      </p:childTnLst>
-                    </p:cTn>
-                  </p:par>
-                  <p:par>
-                    <p:cTn id="15" fill="hold">
-                      <p:stCondLst>
-                        <p:cond delay="indefinite"/>
-                      </p:stCondLst>
-                      <p:childTnLst>
-                        <p:par>
-                          <p:cTn id="16" fill="hold">
-                            <p:stCondLst>
-                              <p:cond delay="0"/>
-                            </p:stCondLst>
-                            <p:childTnLst>
-                              <p:par>
-                                <p:cTn id="17" presetID="1" presetClass="entr" presetSubtype="0" fill="hold" grpId="0" nodeType="clickEffect">
-                                  <p:stCondLst>
-                                    <p:cond delay="0"/>
-                                  </p:stCondLst>
-                                  <p:childTnLst>
-                                    <p:set>
-                                      <p:cBhvr>
-                                        <p:cTn id="18" dur="1" fill="hold">
-                                          <p:stCondLst>
-                                            <p:cond delay="0"/>
-                                          </p:stCondLst>
-                                        </p:cTn>
-                                        <p:tgtEl>
-                                          <p:spTgt spid="3">
-                                            <p:txEl>
-                                              <p:pRg st="4" end="4"/>
-                                            </p:txEl>
-                                          </p:spTgt>
-                                        </p:tgtEl>
-                                        <p:attrNameLst>
-                                          <p:attrName>style.visibility</p:attrName>
-                                        </p:attrNameLst>
-                                      </p:cBhvr>
-                                      <p:to>
-                                        <p:strVal val="visible"/>
-                                      </p:to>
-                                    </p:set>
-                                  </p:childTnLst>
-                                </p:cTn>
-                              </p:par>
-                            </p:childTnLst>
-                          </p:cTn>
-                        </p:par>
-                      </p:childTnLst>
-                    </p:cTn>
-                  </p:par>
-                  <p:par>
-                    <p:cTn id="19" fill="hold">
-                      <p:stCondLst>
-                        <p:cond delay="indefinite"/>
-                      </p:stCondLst>
-                      <p:childTnLst>
-                        <p:par>
-                          <p:cTn id="20" fill="hold">
-                            <p:stCondLst>
-                              <p:cond delay="0"/>
-                            </p:stCondLst>
-                            <p:childTnLst>
-                              <p:par>
-                                <p:cTn id="21" presetID="1" presetClass="entr" presetSubtype="0" fill="hold" grpId="0" nodeType="clickEffect">
-                                  <p:stCondLst>
-                                    <p:cond delay="0"/>
-                                  </p:stCondLst>
-                                  <p:childTnLst>
-                                    <p:set>
-                                      <p:cBhvr>
-                                        <p:cTn id="22" dur="1" fill="hold">
-                                          <p:stCondLst>
-                                            <p:cond delay="0"/>
-                                          </p:stCondLst>
-                                        </p:cTn>
-                                        <p:tgtEl>
-                                          <p:spTgt spid="3">
-                                            <p:txEl>
-                                              <p:pRg st="6" end="6"/>
-                                            </p:txEl>
-                                          </p:spTgt>
-                                        </p:tgtEl>
-                                        <p:attrNameLst>
-                                          <p:attrName>style.visibility</p:attrName>
-                                        </p:attrNameLst>
-                                      </p:cBhvr>
-                                      <p:to>
-                                        <p:strVal val="visible"/>
-                                      </p:to>
-                                    </p:set>
-                                  </p:childTnLst>
-                                </p:cTn>
-                              </p:par>
-                            </p:childTnLst>
-                          </p:cTn>
-                        </p:par>
-                      </p:childTnLst>
-                    </p:cTn>
-                  </p:par>
-                  <p:par>
-                    <p:cTn id="23" fill="hold">
-                      <p:stCondLst>
-                        <p:cond delay="indefinite"/>
-                      </p:stCondLst>
-                      <p:childTnLst>
-                        <p:par>
-                          <p:cTn id="24" fill="hold">
-                            <p:stCondLst>
-                              <p:cond delay="0"/>
-                            </p:stCondLst>
-                            <p:childTnLst>
-                              <p:par>
-                                <p:cTn id="25" presetID="1" presetClass="entr" presetSubtype="0" fill="hold" grpId="0" nodeType="clickEffect">
-                                  <p:stCondLst>
-                                    <p:cond delay="0"/>
-                                  </p:stCondLst>
-                                  <p:childTnLst>
-                                    <p:set>
-                                      <p:cBhvr>
-                                        <p:cTn id="26" dur="1" fill="hold">
-                                          <p:stCondLst>
-                                            <p:cond delay="0"/>
-                                          </p:stCondLst>
-                                        </p:cTn>
-                                        <p:tgtEl>
-                                          <p:spTgt spid="3">
-                                            <p:txEl>
-                                              <p:pRg st="7" end="7"/>
-                                            </p:txEl>
-                                          </p:spTgt>
-                                        </p:tgtEl>
-                                        <p:attrNameLst>
-                                          <p:attrName>style.visibility</p:attrName>
-                                        </p:attrNameLst>
-                                      </p:cBhvr>
-                                      <p:to>
-                                        <p:strVal val="visible"/>
-                                      </p:to>
-                                    </p:set>
-                                  </p:childTnLst>
-                                </p:cTn>
-                              </p:par>
-                            </p:childTnLst>
-                          </p:cTn>
-                        </p:par>
-                      </p:childTnLst>
-                    </p:cTn>
-                  </p:par>
-                  <p:par>
-                    <p:cTn id="27" fill="hold">
-                      <p:stCondLst>
-                        <p:cond delay="indefinite"/>
-                      </p:stCondLst>
-                      <p:childTnLst>
-                        <p:par>
-                          <p:cTn id="28" fill="hold">
-                            <p:stCondLst>
-                              <p:cond delay="0"/>
-                            </p:stCondLst>
-                            <p:childTnLst>
-                              <p:par>
-                                <p:cTn id="29" presetID="1" presetClass="entr" presetSubtype="0" fill="hold" grpId="0" nodeType="clickEffect">
-                                  <p:stCondLst>
-                                    <p:cond delay="0"/>
-                                  </p:stCondLst>
-                                  <p:childTnLst>
-                                    <p:set>
-                                      <p:cBhvr>
-                                        <p:cTn id="30" dur="1" fill="hold">
-                                          <p:stCondLst>
-                                            <p:cond delay="0"/>
-                                          </p:stCondLst>
-                                        </p:cTn>
-                                        <p:tgtEl>
-                                          <p:spTgt spid="3">
-                                            <p:txEl>
-                                              <p:pRg st="8" end="8"/>
-                                            </p:txEl>
-                                          </p:spTgt>
-                                        </p:tgtEl>
-                                        <p:attrNameLst>
-                                          <p:attrName>style.visibility</p:attrName>
-                                        </p:attrNameLst>
-                                      </p:cBhvr>
-                                      <p:to>
-                                        <p:strVal val="visible"/>
-                                      </p:to>
-                                    </p:set>
-                                  </p:childTnLst>
-                                </p:cTn>
-                              </p:par>
-                            </p:childTnLst>
-                          </p:cTn>
-                        </p:par>
-                      </p:childTnLst>
-                    </p:cTn>
-                  </p:par>
-                </p:childTnLst>
-              </p:cTn>
-              <p:prevCondLst>
-                <p:cond evt="onPrev" delay="0">
-                  <p:tgtEl>
-                    <p:sldTgt/>
-                  </p:tgtEl>
-                </p:cond>
-              </p:prevCondLst>
-              <p:nextCondLst>
-                <p:cond evt="onNext" delay="0">
-                  <p:tgtEl>
-                    <p:sldTgt/>
-                  </p:tgtEl>
-                </p:cond>
-              </p:nextCondLst>
-            </p:seq>
-          </p:childTnLst>
-        </p:cTn>
-      </p:par>
-    </p:tnLst>
-    <p:bldLst>
-      <p:bldP spid="3" grpId="0" build="p"/>
-    </p:bldLst>
-  </p:timing>
-</p:sld>
-</file>
-
 <file path=ppt/slides/slide7.xml><?xml version="1.0" encoding="utf-8"?>
 <p:sld xmlns:a="http://schemas.openxmlformats.org/drawingml/2006/main" xmlns:r="http://schemas.openxmlformats.org/officeDocument/2006/relationships" xmlns:p="http://schemas.openxmlformats.org/presentationml/2006/main">
   <p:cSld>
@@ -6048,7 +7649,7 @@
           <p:cNvPr id="2" name="Title 1">
             <a:extLst>
               <a:ext uri="{FF2B5EF4-FFF2-40B4-BE49-F238E27FC236}">
-                <a16:creationId xmlns:a16="http://schemas.microsoft.com/office/drawing/2014/main" id="{566BE9AE-1FEC-417C-9C98-8FB3D8B3CF26}"/>
+                <a16:creationId xmlns:a16="http://schemas.microsoft.com/office/drawing/2014/main" id="{7C7D2508-170C-EFF7-A570-299C185FE942}"/>
               </a:ext>
             </a:extLst>
           </p:cNvPr>
@@ -6065,26 +7666,27 @@
           <a:lstStyle/>
           <a:p>
             <a:r>
-              <a:rPr lang="en-US" dirty="0"/>
-              <a:t>Brightspace</a:t>
-            </a:r>
-            <a:endParaRPr lang="en-CA" dirty="0"/>
+              <a:rPr lang="en-CA" dirty="0"/>
+              <a:t>Rough Schedule of Lectures</a:t>
+            </a:r>
           </a:p>
         </p:txBody>
       </p:sp>
       <p:pic>
         <p:nvPicPr>
-          <p:cNvPr id="7" name="Picture 6">
-            <a:extLst>
-              <a:ext uri="{FF2B5EF4-FFF2-40B4-BE49-F238E27FC236}">
-                <a16:creationId xmlns:a16="http://schemas.microsoft.com/office/drawing/2014/main" id="{C056EBFD-C964-4448-AEA2-E7482709B7AB}"/>
+          <p:cNvPr id="5" name="Content Placeholder 4" descr="A white sheet with black text&#10;&#10;AI-generated content may be incorrect.">
+            <a:extLst>
+              <a:ext uri="{FF2B5EF4-FFF2-40B4-BE49-F238E27FC236}">
+                <a16:creationId xmlns:a16="http://schemas.microsoft.com/office/drawing/2014/main" id="{2F7AD2C0-8AFB-61D8-2A5E-4C25E121E6C5}"/>
               </a:ext>
             </a:extLst>
           </p:cNvPr>
           <p:cNvPicPr>
-            <a:picLocks noChangeAspect="1"/>
+            <a:picLocks noGrp="1" noChangeAspect="1"/>
           </p:cNvPicPr>
-          <p:nvPr/>
+          <p:nvPr>
+            <p:ph idx="1"/>
+          </p:nvPr>
         </p:nvPicPr>
         <p:blipFill>
           <a:blip r:embed="rId2"/>
@@ -6094,8 +7696,8 @@
         </p:blipFill>
         <p:spPr>
           <a:xfrm>
-            <a:off x="2044373" y="1366564"/>
-            <a:ext cx="6981244" cy="5256940"/>
+            <a:off x="1665834" y="1825625"/>
+            <a:ext cx="8860332" cy="4351338"/>
           </a:xfrm>
           <a:prstGeom prst="rect">
             <a:avLst/>
@@ -6105,7 +7707,7 @@
     </p:spTree>
     <p:extLst>
       <p:ext uri="{BB962C8B-B14F-4D97-AF65-F5344CB8AC3E}">
-        <p14:creationId xmlns:p14="http://schemas.microsoft.com/office/powerpoint/2010/main" val="2586454753"/>
+        <p14:creationId xmlns:p14="http://schemas.microsoft.com/office/powerpoint/2010/main" val="37046946"/>
       </p:ext>
     </p:extLst>
   </p:cSld>
@@ -6137,7 +7739,7 @@
           <p:cNvPr id="2" name="Title 1">
             <a:extLst>
               <a:ext uri="{FF2B5EF4-FFF2-40B4-BE49-F238E27FC236}">
-                <a16:creationId xmlns:a16="http://schemas.microsoft.com/office/drawing/2014/main" id="{70A44A35-98C7-4518-99B2-C02BBE9E3AEF}"/>
+                <a16:creationId xmlns:a16="http://schemas.microsoft.com/office/drawing/2014/main" id="{FF541AE4-C02C-C993-73F3-F978CA85E0BF}"/>
               </a:ext>
             </a:extLst>
           </p:cNvPr>
@@ -6154,60 +7756,83 @@
           <a:lstStyle/>
           <a:p>
             <a:r>
-              <a:rPr lang="en-US" dirty="0"/>
-              <a:t>Quizzes</a:t>
-            </a:r>
-            <a:endParaRPr lang="en-CA" dirty="0"/>
-          </a:p>
-        </p:txBody>
-      </p:sp>
-      <p:sp>
-        <p:nvSpPr>
-          <p:cNvPr id="3" name="Content Placeholder 2">
-            <a:extLst>
-              <a:ext uri="{FF2B5EF4-FFF2-40B4-BE49-F238E27FC236}">
-                <a16:creationId xmlns:a16="http://schemas.microsoft.com/office/drawing/2014/main" id="{531A8316-AB8A-4AF3-A550-95303328884C}"/>
-              </a:ext>
-            </a:extLst>
-          </p:cNvPr>
-          <p:cNvSpPr>
-            <a:spLocks noGrp="1"/>
-          </p:cNvSpPr>
+              <a:rPr lang="en-CA" dirty="0"/>
+              <a:t>e.g., Example of Recent “In-Scope” Attack</a:t>
+            </a:r>
+          </a:p>
+        </p:txBody>
+      </p:sp>
+      <p:pic>
+        <p:nvPicPr>
+          <p:cNvPr id="7" name="Content Placeholder 6" descr="A screenshot of a computer&#10;&#10;AI-generated content may be incorrect.">
+            <a:extLst>
+              <a:ext uri="{FF2B5EF4-FFF2-40B4-BE49-F238E27FC236}">
+                <a16:creationId xmlns:a16="http://schemas.microsoft.com/office/drawing/2014/main" id="{266DC0FA-E183-0053-CD71-240CF98A376D}"/>
+              </a:ext>
+            </a:extLst>
+          </p:cNvPr>
+          <p:cNvPicPr>
+            <a:picLocks noGrp="1" noChangeAspect="1"/>
+          </p:cNvPicPr>
           <p:nvPr>
             <p:ph idx="1"/>
           </p:nvPr>
-        </p:nvSpPr>
-        <p:spPr/>
-        <p:txBody>
-          <a:bodyPr/>
-          <a:lstStyle/>
-          <a:p>
-            <a:r>
-              <a:rPr lang="en-US" dirty="0"/>
-              <a:t>We will start quizzes in 2 weeks (next week – no class) – these cover some of the lecture topics.</a:t>
-            </a:r>
-          </a:p>
-          <a:p>
-            <a:pPr lvl="1"/>
-            <a:r>
-              <a:rPr lang="en-US" dirty="0"/>
-              <a:t>They should hopefully reinforce what you’ve learned in the lectures.</a:t>
-            </a:r>
-          </a:p>
-          <a:p>
-            <a:pPr lvl="1"/>
-            <a:r>
-              <a:rPr lang="en-US" dirty="0"/>
-              <a:t>They will run through the Brightspace system.</a:t>
-            </a:r>
-            <a:endParaRPr lang="en-CA" dirty="0"/>
+        </p:nvPicPr>
+        <p:blipFill>
+          <a:blip r:embed="rId2"/>
+          <a:stretch>
+            <a:fillRect/>
+          </a:stretch>
+        </p:blipFill>
+        <p:spPr>
+          <a:xfrm>
+            <a:off x="2122420" y="1825625"/>
+            <a:ext cx="6499904" cy="3558916"/>
+          </a:xfrm>
+          <a:prstGeom prst="rect">
+            <a:avLst/>
+          </a:prstGeom>
+        </p:spPr>
+      </p:pic>
+      <p:sp>
+        <p:nvSpPr>
+          <p:cNvPr id="5" name="TextBox 4">
+            <a:extLst>
+              <a:ext uri="{FF2B5EF4-FFF2-40B4-BE49-F238E27FC236}">
+                <a16:creationId xmlns:a16="http://schemas.microsoft.com/office/drawing/2014/main" id="{04974233-1217-2110-C6AC-DD7679421557}"/>
+              </a:ext>
+            </a:extLst>
+          </p:cNvPr>
+          <p:cNvSpPr txBox="1"/>
+          <p:nvPr/>
+        </p:nvSpPr>
+        <p:spPr>
+          <a:xfrm>
+            <a:off x="1477108" y="5603259"/>
+            <a:ext cx="9671538" cy="369332"/>
+          </a:xfrm>
+          <a:prstGeom prst="rect">
+            <a:avLst/>
+          </a:prstGeom>
+          <a:noFill/>
+        </p:spPr>
+        <p:txBody>
+          <a:bodyPr wrap="square">
+            <a:spAutoFit/>
+          </a:bodyPr>
+          <a:lstStyle/>
+          <a:p>
+            <a:r>
+              <a:rPr lang="en-CA" dirty="0"/>
+              <a:t>https://media.ccc.de/v/39c3-bluetooth-headphone-jacking-a-key-to-your-phone#t=3545</a:t>
+            </a:r>
           </a:p>
         </p:txBody>
       </p:sp>
     </p:spTree>
     <p:extLst>
       <p:ext uri="{BB962C8B-B14F-4D97-AF65-F5344CB8AC3E}">
-        <p14:creationId xmlns:p14="http://schemas.microsoft.com/office/powerpoint/2010/main" val="1255052836"/>
+        <p14:creationId xmlns:p14="http://schemas.microsoft.com/office/powerpoint/2010/main" val="1805635003"/>
       </p:ext>
     </p:extLst>
   </p:cSld>
@@ -6239,7 +7864,7 @@
           <p:cNvPr id="2" name="Title 1">
             <a:extLst>
               <a:ext uri="{FF2B5EF4-FFF2-40B4-BE49-F238E27FC236}">
-                <a16:creationId xmlns:a16="http://schemas.microsoft.com/office/drawing/2014/main" id="{86E81724-3991-44F2-BA6F-17C60556411D}"/>
+                <a16:creationId xmlns:a16="http://schemas.microsoft.com/office/drawing/2014/main" id="{C38C2DD5-3850-D69A-D95D-8FB4E256F259}"/>
               </a:ext>
             </a:extLst>
           </p:cNvPr>
@@ -6256,10 +7881,9 @@
           <a:lstStyle/>
           <a:p>
             <a:r>
-              <a:rPr lang="en-US" dirty="0"/>
-              <a:t>Assignments</a:t>
-            </a:r>
-            <a:endParaRPr lang="en-CA" dirty="0"/>
+              <a:rPr lang="en-CA" dirty="0"/>
+              <a:t>Online to In Person</a:t>
+            </a:r>
           </a:p>
         </p:txBody>
       </p:sp>
@@ -6268,7 +7892,7 @@
           <p:cNvPr id="3" name="Content Placeholder 2">
             <a:extLst>
               <a:ext uri="{FF2B5EF4-FFF2-40B4-BE49-F238E27FC236}">
-                <a16:creationId xmlns:a16="http://schemas.microsoft.com/office/drawing/2014/main" id="{C089213F-51D7-4BCB-A34A-8DD62577C5B9}"/>
+                <a16:creationId xmlns:a16="http://schemas.microsoft.com/office/drawing/2014/main" id="{B2EB9948-0078-F848-0E56-D6EC1BE3348F}"/>
               </a:ext>
             </a:extLst>
           </p:cNvPr>
@@ -6281,19 +7905,58 @@
         </p:nvSpPr>
         <p:spPr/>
         <p:txBody>
-          <a:bodyPr/>
-          <a:lstStyle/>
-          <a:p>
-            <a:r>
-              <a:rPr lang="en-US" dirty="0"/>
-              <a:t>Assignments will be throughout the semester</a:t>
-            </a:r>
-          </a:p>
-          <a:p>
-            <a:pPr lvl="1"/>
-            <a:r>
-              <a:rPr lang="en-US" dirty="0"/>
-              <a:t>One every ~2-3 weeks in final version to avoid overloading you.</a:t>
+          <a:bodyPr>
+            <a:normAutofit fontScale="92500"/>
+          </a:bodyPr>
+          <a:lstStyle/>
+          <a:p>
+            <a:r>
+              <a:rPr lang="en-CA" dirty="0"/>
+              <a:t>I previously taught this course online, this version is different (in-person).</a:t>
+            </a:r>
+          </a:p>
+          <a:p>
+            <a:r>
+              <a:rPr lang="en-CA" dirty="0"/>
+              <a:t>Previous lectures are available (from 2020 year) at </a:t>
+            </a:r>
+            <a:r>
+              <a:rPr lang="en-CA" dirty="0">
+                <a:hlinkClick r:id="rId2"/>
+              </a:rPr>
+              <a:t>https://www.youtube.com/playlist?list=PLyAXNQGte3qNNbs8J3gE8JkpAJ9_OH75q</a:t>
+            </a:r>
+            <a:r>
+              <a:rPr lang="en-CA" dirty="0"/>
+              <a:t> .</a:t>
+            </a:r>
+          </a:p>
+          <a:p>
+            <a:r>
+              <a:rPr lang="en-CA" dirty="0"/>
+              <a:t>Many things (especially assignments/labs) </a:t>
+            </a:r>
+            <a:r>
+              <a:rPr lang="en-CA" u="sng" dirty="0"/>
+              <a:t>changed from previous years.</a:t>
+            </a:r>
+          </a:p>
+          <a:p>
+            <a:r>
+              <a:rPr lang="en-CA" dirty="0"/>
+              <a:t>I try to always record lectures to post on Brightspace.</a:t>
+            </a:r>
+          </a:p>
+          <a:p>
+            <a:r>
+              <a:rPr lang="en-CA" dirty="0"/>
+              <a:t>For online: “Lectures” were short – one class contains multiple lectures!</a:t>
+            </a:r>
+          </a:p>
+          <a:p>
+            <a:r>
+              <a:rPr lang="en-CA" i="1" dirty="0"/>
+              <a:t>Slides this year are more consolidated</a:t>
             </a:r>
           </a:p>
         </p:txBody>
@@ -6301,7 +7964,7 @@
     </p:spTree>
     <p:extLst>
       <p:ext uri="{BB962C8B-B14F-4D97-AF65-F5344CB8AC3E}">
-        <p14:creationId xmlns:p14="http://schemas.microsoft.com/office/powerpoint/2010/main" val="898080511"/>
+        <p14:creationId xmlns:p14="http://schemas.microsoft.com/office/powerpoint/2010/main" val="2482730179"/>
       </p:ext>
     </p:extLst>
   </p:cSld>

</xml_diff>